<commit_message>
Thursday: end with what holds and what doesn't in the paper
Co-Authored-By: Claude Opus 5.5 <noreply@anthropic.com>
</commit_message>
<xml_diff>
--- a/slides/thursday_app.pptx
+++ b/slides/thursday_app.pptx
@@ -27,6 +27,7 @@
     <p:sldId id="275" r:id="rId27"/>
     <p:sldId id="276" r:id="rId28"/>
     <p:sldId id="277" r:id="rId29"/>
+    <p:sldId id="278" r:id="rId30"/>
   </p:sldIdLst>
   <p:sldSz cx="12191695" cy="6858000" type="screen4x3"/>
   <p:notesSz cx="6858000" cy="9144000"/>
@@ -1589,7 +1590,7 @@
           <a:lstStyle/>
           <a:p>
             <a:r>
-              <a:t>Say: Sarah’s bar: nobody leaves without a new insight about designing tools for humans.</a:t>
+              <a:t>Say: Fair to the authors: need-finding from public data is useful, and they published it. What breaks is turning counts of asking into claims about difficulty and skill.</a:t>
             </a:r>
           </a:p>
         </p:txBody>
@@ -1615,6 +1616,76 @@
 </file>
 
 <file path=ppt/notesSlides/notesSlide22.xml><?xml version="1.0" encoding="utf-8"?>
+<p:notes xmlns:a="http://schemas.openxmlformats.org/drawingml/2006/main" xmlns:p="http://schemas.openxmlformats.org/presentationml/2006/main" xmlns:r="http://schemas.openxmlformats.org/officeDocument/2006/relationships">
+  <p:cSld>
+    <p:spTree>
+      <p:nvGrpSpPr>
+        <p:cNvPr id="1" name=""/>
+        <p:cNvGrpSpPr/>
+        <p:nvPr/>
+      </p:nvGrpSpPr>
+      <p:grpSpPr>
+        <a:xfrm>
+          <a:off x="0" y="0"/>
+          <a:ext cx="0" cy="0"/>
+          <a:chOff x="0" y="0"/>
+          <a:chExt cx="0" cy="0"/>
+        </a:xfrm>
+      </p:grpSpPr>
+      <p:sp>
+        <p:nvSpPr>
+          <p:cNvPr id="2" name="Slide Image Placeholder 1"/>
+          <p:cNvSpPr>
+            <a:spLocks noGrp="1"/>
+          </p:cNvSpPr>
+          <p:nvPr>
+            <p:ph type="sldImg" idx="2"/>
+          </p:nvPr>
+        </p:nvSpPr>
+        <p:spPr/>
+      </p:sp>
+      <p:sp>
+        <p:nvSpPr>
+          <p:cNvPr id="3" name="Notes Placeholder 2"/>
+          <p:cNvSpPr>
+            <a:spLocks noGrp="1"/>
+          </p:cNvSpPr>
+          <p:nvPr>
+            <p:ph type="body" idx="3" sz="quarter"/>
+          </p:nvPr>
+        </p:nvSpPr>
+        <p:spPr/>
+        <p:txBody>
+          <a:bodyPr/>
+          <a:lstStyle/>
+          <a:p>
+            <a:r>
+              <a:t>Say: Sarah’s bar: nobody leaves without a new insight about designing tools for humans.</a:t>
+            </a:r>
+          </a:p>
+        </p:txBody>
+      </p:sp>
+      <p:sp>
+        <p:nvSpPr>
+          <p:cNvPr id="4" name="Slide Number Placeholder 3"/>
+          <p:cNvSpPr>
+            <a:spLocks noGrp="1"/>
+          </p:cNvSpPr>
+          <p:nvPr>
+            <p:ph type="sldNum" idx="5" sz="quarter"/>
+          </p:nvPr>
+        </p:nvSpPr>
+        <p:spPr/>
+      </p:sp>
+    </p:spTree>
+  </p:cSld>
+  <p:clrMapOvr>
+    <a:masterClrMapping/>
+  </p:clrMapOvr>
+</p:notes>
+</file>
+
+<file path=ppt/notesSlides/notesSlide23.xml><?xml version="1.0" encoding="utf-8"?>
 <p:notes xmlns:a="http://schemas.openxmlformats.org/drawingml/2006/main" xmlns:p="http://schemas.openxmlformats.org/presentationml/2006/main" xmlns:r="http://schemas.openxmlformats.org/officeDocument/2006/relationships">
   <p:cSld>
     <p:spTree>
@@ -5334,7 +5405,7 @@
                 </a:solidFill>
                 <a:latin typeface="Inter"/>
               </a:rPr>
-              <a:t>CS294 Modern Programming Tools · Thursday · 80 minutes (74 + 6 of buffer)</a:t>
+              <a:t>CS294 Modern Programming Tools · Thursday · 80 minutes (76 + 4 of buffer)</a:t>
             </a:r>
           </a:p>
         </p:txBody>
@@ -11560,7 +11631,7 @@
                 </a:solidFill>
                 <a:latin typeface="Inter"/>
               </a:rPr>
-              <a:t>Each group reads its change, the study that would show it works, and its data. The app shows all of them.</a:t>
+              <a:t>Each group reads its change, its study, its measure and threat, and its data. The app shows all of them.</a:t>
             </a:r>
           </a:p>
         </p:txBody>
@@ -12146,6 +12217,472 @@
     <p:bg>
       <p:bgPr>
         <a:solidFill>
+          <a:srgbClr val="FFFFFF"/>
+        </a:solidFill>
+        <a:effectLst/>
+      </p:bgPr>
+    </p:bg>
+    <p:spTree>
+      <p:nvGrpSpPr>
+        <p:cNvPr id="1" name=""/>
+        <p:cNvGrpSpPr/>
+        <p:nvPr/>
+      </p:nvGrpSpPr>
+      <p:grpSpPr/>
+      <p:sp>
+        <p:nvSpPr>
+          <p:cNvPr id="2" name="TextBox 1"/>
+          <p:cNvSpPr txBox="1"/>
+          <p:nvPr/>
+        </p:nvSpPr>
+        <p:spPr>
+          <a:xfrm>
+            <a:off x="822960" y="502920"/>
+            <a:ext cx="10545775" cy="320040"/>
+          </a:xfrm>
+          <a:prstGeom prst="rect">
+            <a:avLst/>
+          </a:prstGeom>
+          <a:noFill/>
+        </p:spPr>
+        <p:txBody>
+          <a:bodyPr wrap="square" anchor="t" lIns="0" rIns="0" tIns="0" bIns="0"/>
+          <a:lstStyle/>
+          <a:p>
+            <a:pPr algn="l">
+              <a:lnSpc>
+                <a:spcPct val="110000"/>
+              </a:lnSpc>
+            </a:pPr>
+            <a:r>
+              <a:rPr sz="1600" b="1">
+                <a:solidFill>
+                  <a:srgbClr val="8B3DFF"/>
+                </a:solidFill>
+                <a:latin typeface="Inter"/>
+              </a:rPr>
+              <a:t>THURSDAY</a:t>
+            </a:r>
+          </a:p>
+        </p:txBody>
+      </p:sp>
+      <p:sp>
+        <p:nvSpPr>
+          <p:cNvPr id="3" name="TextBox 2"/>
+          <p:cNvSpPr txBox="1"/>
+          <p:nvPr/>
+        </p:nvSpPr>
+        <p:spPr>
+          <a:xfrm>
+            <a:off x="822960" y="868680"/>
+            <a:ext cx="10545775" cy="688441"/>
+          </a:xfrm>
+          <a:prstGeom prst="rect">
+            <a:avLst/>
+          </a:prstGeom>
+          <a:noFill/>
+        </p:spPr>
+        <p:txBody>
+          <a:bodyPr wrap="square" anchor="t" lIns="0" rIns="0" tIns="0" bIns="0"/>
+          <a:lstStyle/>
+          <a:p>
+            <a:pPr algn="l">
+              <a:lnSpc>
+                <a:spcPct val="112000"/>
+              </a:lnSpc>
+              <a:spcBef>
+                <a:spcPts val="0"/>
+              </a:spcBef>
+            </a:pPr>
+            <a:r>
+              <a:rPr sz="4000" b="1" i="0">
+                <a:solidFill>
+                  <a:srgbClr val="111111"/>
+                </a:solidFill>
+                <a:latin typeface="Inter"/>
+              </a:rPr>
+              <a:t>The paper: what holds, what doesn’t</a:t>
+            </a:r>
+          </a:p>
+        </p:txBody>
+      </p:sp>
+      <p:sp>
+        <p:nvSpPr>
+          <p:cNvPr id="4" name="TextBox 3"/>
+          <p:cNvSpPr txBox="1"/>
+          <p:nvPr/>
+        </p:nvSpPr>
+        <p:spPr>
+          <a:xfrm>
+            <a:off x="822960" y="1831441"/>
+            <a:ext cx="5044287" cy="365760"/>
+          </a:xfrm>
+          <a:prstGeom prst="rect">
+            <a:avLst/>
+          </a:prstGeom>
+          <a:noFill/>
+        </p:spPr>
+        <p:txBody>
+          <a:bodyPr wrap="square" anchor="t" lIns="0" rIns="0" tIns="0" bIns="0"/>
+          <a:lstStyle/>
+          <a:p>
+            <a:pPr algn="l">
+              <a:lnSpc>
+                <a:spcPct val="110000"/>
+              </a:lnSpc>
+            </a:pPr>
+            <a:r>
+              <a:rPr sz="2000" b="1">
+                <a:solidFill>
+                  <a:srgbClr val="16A34A"/>
+                </a:solidFill>
+                <a:latin typeface="Inter"/>
+              </a:rPr>
+              <a:t>Holds</a:t>
+            </a:r>
+          </a:p>
+        </p:txBody>
+      </p:sp>
+      <p:sp>
+        <p:nvSpPr>
+          <p:cNvPr id="5" name="Rectangle 4"/>
+          <p:cNvSpPr/>
+          <p:nvPr/>
+        </p:nvSpPr>
+        <p:spPr>
+          <a:xfrm>
+            <a:off x="822960" y="2242921"/>
+            <a:ext cx="5044287" cy="45720"/>
+          </a:xfrm>
+          <a:prstGeom prst="rect">
+            <a:avLst/>
+          </a:prstGeom>
+          <a:solidFill>
+            <a:srgbClr val="16A34A"/>
+          </a:solidFill>
+          <a:ln>
+            <a:noFill/>
+          </a:ln>
+        </p:spPr>
+        <p:txBody>
+          <a:bodyPr rtlCol="0" anchor="ctr"/>
+          <a:lstStyle/>
+          <a:p>
+            <a:pPr algn="ctr"/>
+          </a:p>
+        </p:txBody>
+      </p:sp>
+      <p:sp>
+        <p:nvSpPr>
+          <p:cNvPr id="6" name="TextBox 5"/>
+          <p:cNvSpPr txBox="1"/>
+          <p:nvPr/>
+        </p:nvSpPr>
+        <p:spPr>
+          <a:xfrm>
+            <a:off x="822960" y="2380081"/>
+            <a:ext cx="5044287" cy="2507812"/>
+          </a:xfrm>
+          <a:prstGeom prst="rect">
+            <a:avLst/>
+          </a:prstGeom>
+          <a:noFill/>
+        </p:spPr>
+        <p:txBody>
+          <a:bodyPr wrap="square" anchor="t" lIns="0" rIns="0" tIns="0" bIns="0"/>
+          <a:lstStyle/>
+          <a:p>
+            <a:pPr algn="l">
+              <a:lnSpc>
+                <a:spcPct val="112000"/>
+              </a:lnSpc>
+              <a:spcBef>
+                <a:spcPts val="0"/>
+              </a:spcBef>
+            </a:pPr>
+            <a:r>
+              <a:rPr sz="1600" b="0" i="0">
+                <a:solidFill>
+                  <a:srgbClr val="111111"/>
+                </a:solidFill>
+                <a:latin typeface="Inter"/>
+              </a:rPr>
+              <a:t>✓ Git questions are many, and steady: about 0.4% of Stack Overflow a year.</a:t>
+            </a:r>
+          </a:p>
+          <a:p>
+            <a:pPr algn="l">
+              <a:lnSpc>
+                <a:spcPct val="112000"/>
+              </a:lnSpc>
+              <a:spcBef>
+                <a:spcPts val="800"/>
+              </a:spcBef>
+            </a:pPr>
+            <a:r>
+              <a:rPr sz="1600" b="0" i="0">
+                <a:solidFill>
+                  <a:srgbClr val="111111"/>
+                </a:solidFill>
+                <a:latin typeface="Inter"/>
+              </a:rPr>
+              <a:t>✓ Undo is a real need: the most-viewed Git question asks how to undo a commit.</a:t>
+            </a:r>
+          </a:p>
+          <a:p>
+            <a:pPr algn="l">
+              <a:lnSpc>
+                <a:spcPct val="112000"/>
+              </a:lnSpc>
+              <a:spcBef>
+                <a:spcPts val="800"/>
+              </a:spcBef>
+            </a:pPr>
+            <a:r>
+              <a:rPr sz="1600" b="0" i="0">
+                <a:solidFill>
+                  <a:srgbClr val="111111"/>
+                </a:solidFill>
+                <a:latin typeface="Inter"/>
+              </a:rPr>
+              <a:t>✓ Experienced developers can have trouble: true, as written.</a:t>
+            </a:r>
+          </a:p>
+          <a:p>
+            <a:pPr algn="l">
+              <a:lnSpc>
+                <a:spcPct val="112000"/>
+              </a:lnSpc>
+              <a:spcBef>
+                <a:spcPts val="800"/>
+              </a:spcBef>
+            </a:pPr>
+            <a:r>
+              <a:rPr sz="1600" b="0" i="0">
+                <a:solidFill>
+                  <a:srgbClr val="111111"/>
+                </a:solidFill>
+                <a:latin typeface="Inter"/>
+              </a:rPr>
+              <a:t>✓ The data is public, so anyone can check it. We did.</a:t>
+            </a:r>
+          </a:p>
+        </p:txBody>
+      </p:sp>
+      <p:sp>
+        <p:nvSpPr>
+          <p:cNvPr id="7" name="TextBox 6"/>
+          <p:cNvSpPr txBox="1"/>
+          <p:nvPr/>
+        </p:nvSpPr>
+        <p:spPr>
+          <a:xfrm>
+            <a:off x="6324447" y="1831441"/>
+            <a:ext cx="5044287" cy="365760"/>
+          </a:xfrm>
+          <a:prstGeom prst="rect">
+            <a:avLst/>
+          </a:prstGeom>
+          <a:noFill/>
+        </p:spPr>
+        <p:txBody>
+          <a:bodyPr wrap="square" anchor="t" lIns="0" rIns="0" tIns="0" bIns="0"/>
+          <a:lstStyle/>
+          <a:p>
+            <a:pPr algn="l">
+              <a:lnSpc>
+                <a:spcPct val="110000"/>
+              </a:lnSpc>
+            </a:pPr>
+            <a:r>
+              <a:rPr sz="2000" b="1">
+                <a:solidFill>
+                  <a:srgbClr val="DC2626"/>
+                </a:solidFill>
+                <a:latin typeface="Inter"/>
+              </a:rPr>
+              <a:t>Does not hold, as written</a:t>
+            </a:r>
+          </a:p>
+        </p:txBody>
+      </p:sp>
+      <p:sp>
+        <p:nvSpPr>
+          <p:cNvPr id="8" name="Rectangle 7"/>
+          <p:cNvSpPr/>
+          <p:nvPr/>
+        </p:nvSpPr>
+        <p:spPr>
+          <a:xfrm>
+            <a:off x="6324447" y="2242921"/>
+            <a:ext cx="5044287" cy="45720"/>
+          </a:xfrm>
+          <a:prstGeom prst="rect">
+            <a:avLst/>
+          </a:prstGeom>
+          <a:solidFill>
+            <a:srgbClr val="DC2626"/>
+          </a:solidFill>
+          <a:ln>
+            <a:noFill/>
+          </a:ln>
+        </p:spPr>
+        <p:txBody>
+          <a:bodyPr rtlCol="0" anchor="ctr"/>
+          <a:lstStyle/>
+          <a:p>
+            <a:pPr algn="ctr"/>
+          </a:p>
+        </p:txBody>
+      </p:sp>
+      <p:sp>
+        <p:nvSpPr>
+          <p:cNvPr id="9" name="TextBox 8"/>
+          <p:cNvSpPr txBox="1"/>
+          <p:nvPr/>
+        </p:nvSpPr>
+        <p:spPr>
+          <a:xfrm>
+            <a:off x="6324447" y="2380081"/>
+            <a:ext cx="5044287" cy="3160165"/>
+          </a:xfrm>
+          <a:prstGeom prst="rect">
+            <a:avLst/>
+          </a:prstGeom>
+          <a:noFill/>
+        </p:spPr>
+        <p:txBody>
+          <a:bodyPr wrap="square" anchor="t" lIns="0" rIns="0" tIns="0" bIns="0"/>
+          <a:lstStyle/>
+          <a:p>
+            <a:pPr algn="l">
+              <a:lnSpc>
+                <a:spcPct val="112000"/>
+              </a:lnSpc>
+              <a:spcBef>
+                <a:spcPts val="0"/>
+              </a:spcBef>
+            </a:pPr>
+            <a:r>
+              <a:rPr sz="1600" b="0" i="0">
+                <a:solidFill>
+                  <a:srgbClr val="111111"/>
+                </a:solidFill>
+                <a:latin typeface="Inter"/>
+              </a:rPr>
+              <a:t>✗ “Hardest commands”: the rule counts fixes in answers as problems.</a:t>
+            </a:r>
+          </a:p>
+          <a:p>
+            <a:pPr algn="l">
+              <a:lnSpc>
+                <a:spcPct val="112000"/>
+              </a:lnSpc>
+              <a:spcBef>
+                <a:spcPts val="800"/>
+              </a:spcBef>
+            </a:pPr>
+            <a:r>
+              <a:rPr sz="1600" b="0" i="0">
+                <a:solidFill>
+                  <a:srgbClr val="111111"/>
+                </a:solidFill>
+                <a:latin typeface="Inter"/>
+              </a:rPr>
+              <a:t>✗ The command ranking: one post moves </a:t>
+            </a:r>
+            <a:r>
+              <a:rPr sz="1600" b="0" i="0">
+                <a:solidFill>
+                  <a:srgbClr val="111111"/>
+                </a:solidFill>
+                <a:latin typeface="Noto Sans Mono"/>
+              </a:rPr>
+              <a:t>git reflog</a:t>
+            </a:r>
+            <a:r>
+              <a:rPr sz="1600" b="0" i="0">
+                <a:solidFill>
+                  <a:srgbClr val="111111"/>
+                </a:solidFill>
+                <a:latin typeface="Inter"/>
+              </a:rPr>
+              <a:t> from #8 to #2.</a:t>
+            </a:r>
+          </a:p>
+          <a:p>
+            <a:pPr algn="l">
+              <a:lnSpc>
+                <a:spcPct val="112000"/>
+              </a:lnSpc>
+              <a:spcBef>
+                <a:spcPts val="800"/>
+              </a:spcBef>
+            </a:pPr>
+            <a:r>
+              <a:rPr sz="1600" b="0" i="0">
+                <a:solidFill>
+                  <a:srgbClr val="111111"/>
+                </a:solidFill>
+                <a:latin typeface="Inter"/>
+              </a:rPr>
+              <a:t>✗ “Self-learning is primary”: asked of people found on Stack Overflow.</a:t>
+            </a:r>
+          </a:p>
+          <a:p>
+            <a:pPr algn="l">
+              <a:lnSpc>
+                <a:spcPct val="112000"/>
+              </a:lnSpc>
+              <a:spcBef>
+                <a:spcPts val="800"/>
+              </a:spcBef>
+            </a:pPr>
+            <a:r>
+              <a:rPr sz="1600" b="0" i="0">
+                <a:solidFill>
+                  <a:srgbClr val="111111"/>
+                </a:solidFill>
+                <a:latin typeface="Inter"/>
+              </a:rPr>
+              <a:t>✗ Table 8 and “doubts”: no coding method; self-ratings, not skill.</a:t>
+            </a:r>
+          </a:p>
+          <a:p>
+            <a:pPr algn="l">
+              <a:lnSpc>
+                <a:spcPct val="112000"/>
+              </a:lnSpc>
+              <a:spcBef>
+                <a:spcPts val="800"/>
+              </a:spcBef>
+            </a:pPr>
+            <a:r>
+              <a:rPr sz="1600" b="0" i="0">
+                <a:solidFill>
+                  <a:srgbClr val="111111"/>
+                </a:solidFill>
+                <a:latin typeface="Inter"/>
+              </a:rPr>
+              <a:t>✗ The title’s question: nobody was watched using Git.</a:t>
+            </a:r>
+          </a:p>
+        </p:txBody>
+      </p:sp>
+    </p:spTree>
+  </p:cSld>
+  <p:clrMapOvr>
+    <a:masterClrMapping/>
+  </p:clrMapOvr>
+</p:sld>
+</file>
+
+<file path=ppt/slides/slide22.xml><?xml version="1.0" encoding="utf-8"?>
+<p:sld xmlns:a="http://schemas.openxmlformats.org/drawingml/2006/main" xmlns:p="http://schemas.openxmlformats.org/presentationml/2006/main" xmlns:r="http://schemas.openxmlformats.org/officeDocument/2006/relationships">
+  <p:cSld>
+    <p:bg>
+      <p:bgPr>
+        <a:solidFill>
           <a:srgbClr val="F4ECFB"/>
         </a:solidFill>
         <a:effectLst/>
@@ -12324,7 +12861,7 @@
 </p:sld>
 </file>
 
-<file path=ppt/slides/slide22.xml><?xml version="1.0" encoding="utf-8"?>
+<file path=ppt/slides/slide23.xml><?xml version="1.0" encoding="utf-8"?>
 <p:sld xmlns:a="http://schemas.openxmlformats.org/drawingml/2006/main" xmlns:p="http://schemas.openxmlformats.org/presentationml/2006/main" xmlns:r="http://schemas.openxmlformats.org/officeDocument/2006/relationships">
   <p:cSld>
     <p:bg>

</xml_diff>

<commit_message>
Five editing rounds over every screen and slide of both days
Round 1: the old word 'note' removed from every student line; deck card
labels measured; exit line shortened. Round 2: Step 4 opening shortened
(the fresh-copy line already says it); survey slide exact (508 asked, 92
answered); seed and script path off the class slide. Round 3: 'long-time
users' made exact (Stack Overflow account age). Rounds 4-5: nothing left to
change. Tests: 96/96; both days' browser runs and rehearsals; both decks.

Co-Authored-By: Claude Fable 5.1 <noreply@anthropic.com>
</commit_message>
<xml_diff>
--- a/slides/thursday_app.pptx
+++ b/slides/thursday_app.pptx
@@ -6484,7 +6484,7 @@
         <p:spPr>
           <a:xfrm>
             <a:off x="822960" y="2875481"/>
-            <a:ext cx="5181447" cy="1313992"/>
+            <a:ext cx="5181447" cy="1302145"/>
           </a:xfrm>
           <a:prstGeom prst="roundRect">
             <a:avLst>
@@ -6516,7 +6516,7 @@
         <p:spPr>
           <a:xfrm>
             <a:off x="1005840" y="3012641"/>
-            <a:ext cx="4815687" cy="201168"/>
+            <a:ext cx="4815687" cy="189321"/>
           </a:xfrm>
           <a:prstGeom prst="rect">
             <a:avLst/>
@@ -6552,7 +6552,7 @@
         </p:nvSpPr>
         <p:spPr>
           <a:xfrm>
-            <a:off x="1005840" y="3232097"/>
+            <a:off x="1005840" y="3220250"/>
             <a:ext cx="4815687" cy="774496"/>
           </a:xfrm>
           <a:prstGeom prst="rect">
@@ -6593,7 +6593,7 @@
         <p:spPr>
           <a:xfrm>
             <a:off x="6187287" y="2875481"/>
-            <a:ext cx="5181447" cy="1313992"/>
+            <a:ext cx="5181447" cy="1302145"/>
           </a:xfrm>
           <a:prstGeom prst="roundRect">
             <a:avLst>
@@ -6625,7 +6625,7 @@
         <p:spPr>
           <a:xfrm>
             <a:off x="6370167" y="3012641"/>
-            <a:ext cx="4815687" cy="201168"/>
+            <a:ext cx="4815687" cy="189321"/>
           </a:xfrm>
           <a:prstGeom prst="rect">
             <a:avLst/>
@@ -6661,7 +6661,7 @@
         </p:nvSpPr>
         <p:spPr>
           <a:xfrm>
-            <a:off x="6370167" y="3232097"/>
+            <a:off x="6370167" y="3220250"/>
             <a:ext cx="4815687" cy="774496"/>
           </a:xfrm>
           <a:prstGeom prst="rect">
@@ -6701,8 +6701,8 @@
         </p:nvSpPr>
         <p:spPr>
           <a:xfrm>
-            <a:off x="822960" y="4372353"/>
-            <a:ext cx="5181447" cy="1572158"/>
+            <a:off x="822960" y="4360506"/>
+            <a:ext cx="5181447" cy="1560311"/>
           </a:xfrm>
           <a:prstGeom prst="roundRect">
             <a:avLst>
@@ -6733,8 +6733,8 @@
         </p:nvSpPr>
         <p:spPr>
           <a:xfrm>
-            <a:off x="1005840" y="4509513"/>
-            <a:ext cx="4815687" cy="201168"/>
+            <a:off x="1005840" y="4497666"/>
+            <a:ext cx="4815687" cy="189321"/>
           </a:xfrm>
           <a:prstGeom prst="rect">
             <a:avLst/>
@@ -6770,7 +6770,7 @@
         </p:nvSpPr>
         <p:spPr>
           <a:xfrm>
-            <a:off x="1005840" y="4728969"/>
+            <a:off x="1005840" y="4705275"/>
             <a:ext cx="4815687" cy="258165"/>
           </a:xfrm>
           <a:prstGeom prst="rect">
@@ -6810,8 +6810,8 @@
         </p:nvSpPr>
         <p:spPr>
           <a:xfrm>
-            <a:off x="6187287" y="4372353"/>
-            <a:ext cx="5181447" cy="1572158"/>
+            <a:off x="6187287" y="4360506"/>
+            <a:ext cx="5181447" cy="1560311"/>
           </a:xfrm>
           <a:prstGeom prst="roundRect">
             <a:avLst>
@@ -6842,8 +6842,8 @@
         </p:nvSpPr>
         <p:spPr>
           <a:xfrm>
-            <a:off x="6370167" y="4509513"/>
-            <a:ext cx="4815687" cy="201168"/>
+            <a:off x="6370167" y="4497666"/>
+            <a:ext cx="4815687" cy="189321"/>
           </a:xfrm>
           <a:prstGeom prst="rect">
             <a:avLst/>
@@ -6879,7 +6879,7 @@
         </p:nvSpPr>
         <p:spPr>
           <a:xfrm>
-            <a:off x="6370167" y="4728969"/>
+            <a:off x="6370167" y="4705275"/>
             <a:ext cx="4815687" cy="1032662"/>
           </a:xfrm>
           <a:prstGeom prst="rect">
@@ -8205,7 +8205,7 @@
         <p:spPr>
           <a:xfrm>
             <a:off x="822960" y="2806637"/>
-            <a:ext cx="2499283" cy="1503314"/>
+            <a:ext cx="2499283" cy="1680788"/>
           </a:xfrm>
           <a:prstGeom prst="roundRect">
             <a:avLst>
@@ -8237,7 +8237,7 @@
         <p:spPr>
           <a:xfrm>
             <a:off x="1005840" y="2943797"/>
-            <a:ext cx="2133523" cy="201168"/>
+            <a:ext cx="2133523" cy="189321"/>
           </a:xfrm>
           <a:prstGeom prst="rect">
             <a:avLst/>
@@ -8273,7 +8273,7 @@
         </p:nvSpPr>
         <p:spPr>
           <a:xfrm>
-            <a:off x="1005840" y="3163253"/>
+            <a:off x="1005840" y="3151406"/>
             <a:ext cx="2133523" cy="481909"/>
           </a:xfrm>
           <a:prstGeom prst="rect">
@@ -8314,7 +8314,7 @@
         <p:spPr>
           <a:xfrm>
             <a:off x="3505123" y="2806637"/>
-            <a:ext cx="2499283" cy="1503314"/>
+            <a:ext cx="2499283" cy="1680788"/>
           </a:xfrm>
           <a:prstGeom prst="roundRect">
             <a:avLst>
@@ -8346,7 +8346,7 @@
         <p:spPr>
           <a:xfrm>
             <a:off x="3688003" y="2943797"/>
-            <a:ext cx="2133523" cy="201168"/>
+            <a:ext cx="2133523" cy="189321"/>
           </a:xfrm>
           <a:prstGeom prst="rect">
             <a:avLst/>
@@ -8382,7 +8382,7 @@
         </p:nvSpPr>
         <p:spPr>
           <a:xfrm>
-            <a:off x="3688003" y="3163253"/>
+            <a:off x="3688003" y="3151406"/>
             <a:ext cx="2133523" cy="722863"/>
           </a:xfrm>
           <a:prstGeom prst="rect">
@@ -8423,7 +8423,7 @@
         <p:spPr>
           <a:xfrm>
             <a:off x="6187286" y="2806637"/>
-            <a:ext cx="2499283" cy="1503314"/>
+            <a:ext cx="2499283" cy="1680788"/>
           </a:xfrm>
           <a:prstGeom prst="roundRect">
             <a:avLst>
@@ -8455,7 +8455,7 @@
         <p:spPr>
           <a:xfrm>
             <a:off x="6370166" y="2943797"/>
-            <a:ext cx="2133523" cy="201168"/>
+            <a:ext cx="2133523" cy="378642"/>
           </a:xfrm>
           <a:prstGeom prst="rect">
             <a:avLst/>
@@ -8491,7 +8491,7 @@
         </p:nvSpPr>
         <p:spPr>
           <a:xfrm>
-            <a:off x="6370166" y="3163253"/>
+            <a:off x="6370166" y="3340727"/>
             <a:ext cx="2133523" cy="963818"/>
           </a:xfrm>
           <a:prstGeom prst="rect">
@@ -8532,7 +8532,7 @@
         <p:spPr>
           <a:xfrm>
             <a:off x="8869449" y="2806637"/>
-            <a:ext cx="2499283" cy="1503314"/>
+            <a:ext cx="2499283" cy="1680788"/>
           </a:xfrm>
           <a:prstGeom prst="roundRect">
             <a:avLst>
@@ -8564,7 +8564,7 @@
         <p:spPr>
           <a:xfrm>
             <a:off x="9052329" y="2943797"/>
-            <a:ext cx="2133523" cy="201168"/>
+            <a:ext cx="2133523" cy="378642"/>
           </a:xfrm>
           <a:prstGeom prst="rect">
             <a:avLst/>
@@ -8600,7 +8600,7 @@
         </p:nvSpPr>
         <p:spPr>
           <a:xfrm>
-            <a:off x="9052329" y="3163253"/>
+            <a:off x="9052329" y="3340727"/>
             <a:ext cx="2133523" cy="722863"/>
           </a:xfrm>
           <a:prstGeom prst="rect">
@@ -8770,7 +8770,7 @@
                 </a:solidFill>
                 <a:latin typeface="Inter"/>
               </a:rPr>
-              <a:t>Each group reads its change, its study, its measure and threat, and its data. The app shows all of them.</a:t>
+              <a:t>Each group reads its change, its test, its measure and risk, and its data. The app shows all of them.</a:t>
             </a:r>
           </a:p>
         </p:txBody>
@@ -8993,7 +8993,7 @@
         <p:spPr>
           <a:xfrm>
             <a:off x="822960" y="3068523"/>
-            <a:ext cx="5044287" cy="1957058"/>
+            <a:ext cx="5044287" cy="2232435"/>
           </a:xfrm>
           <a:prstGeom prst="rect">
             <a:avLst/>
@@ -9057,7 +9057,7 @@
                 </a:solidFill>
                 <a:latin typeface="Inter"/>
               </a:rPr>
-              <a:t>✓ Long-time users can still get stuck.</a:t>
+              <a:t>✓ Long-time Stack Overflow users can still get stuck.</a:t>
             </a:r>
           </a:p>
           <a:p>
@@ -9979,7 +9979,7 @@
         <p:spPr>
           <a:xfrm>
             <a:off x="822960" y="1831441"/>
-            <a:ext cx="8647535" cy="884284"/>
+            <a:ext cx="8647535" cy="1262927"/>
           </a:xfrm>
           <a:prstGeom prst="rect">
             <a:avLst/>
@@ -10005,7 +10005,7 @@
                 </a:solidFill>
                 <a:latin typeface="Inter"/>
               </a:rPr>
-              <a:t>These are the questions the paper asked 92 developers.</a:t>
+              <a:t>These are the paper’s survey questions, which 92 developers answered.</a:t>
             </a:r>
           </a:p>
           <a:p>
@@ -10037,7 +10037,7 @@
         </p:nvSpPr>
         <p:spPr>
           <a:xfrm>
-            <a:off x="822960" y="2944325"/>
+            <a:off x="822960" y="3322968"/>
             <a:ext cx="8647535" cy="1969756"/>
           </a:xfrm>
           <a:prstGeom prst="rect">
@@ -10172,7 +10172,7 @@
         </p:nvSpPr>
         <p:spPr>
           <a:xfrm>
-            <a:off x="822960" y="5051241"/>
+            <a:off x="822960" y="5429884"/>
             <a:ext cx="8647535" cy="223743"/>
           </a:xfrm>
           <a:prstGeom prst="rect">
@@ -11059,7 +11059,7 @@
                 </a:solidFill>
                 <a:latin typeface="Inter"/>
               </a:rPr>
-              <a:t>Many askers are long-time users. In 2020, 40% had joined Stack Overflow more than 5 years earlier.</a:t>
+              <a:t>Many askers have old Stack Overflow accounts. In 2020, 40% had joined more than 5 years earlier.</a:t>
             </a:r>
           </a:p>
         </p:txBody>
@@ -13585,7 +13585,7 @@
         <p:spPr>
           <a:xfrm>
             <a:off x="822960" y="3322968"/>
-            <a:ext cx="3393338" cy="1021405"/>
+            <a:ext cx="3393338" cy="1009558"/>
           </a:xfrm>
           <a:prstGeom prst="roundRect">
             <a:avLst>
@@ -13617,7 +13617,7 @@
         <p:spPr>
           <a:xfrm>
             <a:off x="1005840" y="3460128"/>
-            <a:ext cx="3027578" cy="201168"/>
+            <a:ext cx="3027578" cy="189321"/>
           </a:xfrm>
           <a:prstGeom prst="rect">
             <a:avLst/>
@@ -13653,7 +13653,7 @@
         </p:nvSpPr>
         <p:spPr>
           <a:xfrm>
-            <a:off x="1005840" y="3679584"/>
+            <a:off x="1005840" y="3667737"/>
             <a:ext cx="3027578" cy="481909"/>
           </a:xfrm>
           <a:prstGeom prst="rect">
@@ -13694,7 +13694,7 @@
         <p:spPr>
           <a:xfrm>
             <a:off x="4399178" y="3322968"/>
-            <a:ext cx="3393338" cy="1021405"/>
+            <a:ext cx="3393338" cy="1009558"/>
           </a:xfrm>
           <a:prstGeom prst="roundRect">
             <a:avLst>
@@ -13726,7 +13726,7 @@
         <p:spPr>
           <a:xfrm>
             <a:off x="4582058" y="3460128"/>
-            <a:ext cx="3027578" cy="201168"/>
+            <a:ext cx="3027578" cy="189321"/>
           </a:xfrm>
           <a:prstGeom prst="rect">
             <a:avLst/>
@@ -13762,7 +13762,7 @@
         </p:nvSpPr>
         <p:spPr>
           <a:xfrm>
-            <a:off x="4582058" y="3679584"/>
+            <a:off x="4582058" y="3667737"/>
             <a:ext cx="3027578" cy="481909"/>
           </a:xfrm>
           <a:prstGeom prst="rect">
@@ -13803,7 +13803,7 @@
         <p:spPr>
           <a:xfrm>
             <a:off x="7975396" y="3322968"/>
-            <a:ext cx="3393338" cy="1021405"/>
+            <a:ext cx="3393338" cy="1009558"/>
           </a:xfrm>
           <a:prstGeom prst="roundRect">
             <a:avLst>
@@ -13835,7 +13835,7 @@
         <p:spPr>
           <a:xfrm>
             <a:off x="8158276" y="3460128"/>
-            <a:ext cx="3027578" cy="201168"/>
+            <a:ext cx="3027578" cy="189321"/>
           </a:xfrm>
           <a:prstGeom prst="rect">
             <a:avLst/>
@@ -13871,7 +13871,7 @@
         </p:nvSpPr>
         <p:spPr>
           <a:xfrm>
-            <a:off x="8158276" y="3679584"/>
+            <a:off x="8158276" y="3667737"/>
             <a:ext cx="3027578" cy="481909"/>
           </a:xfrm>
           <a:prstGeom prst="rect">
@@ -13911,7 +13911,7 @@
         </p:nvSpPr>
         <p:spPr>
           <a:xfrm>
-            <a:off x="822960" y="4572973"/>
+            <a:off x="822960" y="4561126"/>
             <a:ext cx="8647535" cy="1152306"/>
           </a:xfrm>
           <a:prstGeom prst="rect">
@@ -13957,7 +13957,7 @@
                 </a:solidFill>
                 <a:latin typeface="Inter"/>
               </a:rPr>
-              <a:t>Drawn at random from short, answered posts credited to the top-5 commands (analysis/thursday_numbers.py, seed 294).</a:t>
+              <a:t>Drawn at random from short, answered posts counted for the five most-viewed commands.</a:t>
             </a:r>
           </a:p>
         </p:txBody>

</xml_diff>

<commit_message>
Thursday claims: the facts behind each claim are on the student's screen; nobody needs the paper
Co-Authored-By: Claude Fable 5.1 <noreply@anthropic.com>
</commit_message>
<xml_diff>
--- a/slides/thursday_app.pptx
+++ b/slides/thursday_app.pptx
@@ -742,33 +742,33 @@
           <a:lstStyle/>
           <a:p>
             <a:r>
-              <a:t>Say: One claim per group. The paper is open on their laptops; the hint points to the section.</a:t>
+              <a:t>Say: One claim per group. Everything they need is on their screen: the claim and the facts behind it. Nobody needs the paper.</a:t>
             </a:r>
           </a:p>
           <a:p/>
           <a:p>
             <a:r>
-              <a:t>The hint each group sees:</a:t>
-            </a:r>
-          </a:p>
-          <a:p>
-            <a:r>
-              <a:t>- "This suggests that even developers with years of development experience can have trouble using Git commands." Look at: How did the authors measure experience? See §2.1 Step 4 and §5.</a:t>
-            </a:r>
-          </a:p>
-          <a:p>
-            <a:r>
-              <a:t>- "…for the more frequently-used commands, git credential and git submodule are among the most difficult ones." Look at: What does “difficult” mean in §3.4? For comparison, 36.5% of all the Git questions have no accepted answer (our count on the paper’s data).</a:t>
-            </a:r>
-          </a:p>
-          <a:p>
-            <a:r>
-              <a:t>- "Self-learning is the primary learning approach." Look at: Who was asked, and how were they found? See §2.2.</a:t>
-            </a:r>
-          </a:p>
-          <a:p>
-            <a:r>
-              <a:t>- "This result, although surprising, is consistent with the conclusion we obtained in RQ2, indicating that even experienced developers still have doubts about Git usage." Look at: What is the evidence for “doubts”? See §3.5 and Figure 4.</a:t>
+              <a:t>The facts each group sees with its claim:</a:t>
+            </a:r>
+          </a:p>
+          <a:p>
+            <a:r>
+              <a:t>- "This suggests that even developers with years of development experience can have trouble using Git commands." The authors measured experience as the years since the asker joined Stack Overflow. In 2020, 40.0% of Git askers had joined more than 5 years earlier. Among all Stack Overflow askers, 21.2% had. The authors themselves call this a stand-in for experience (§5). Two askers are quoted saying they have programmed for years and still struggle with Git.</a:t>
+            </a:r>
+          </a:p>
+          <a:p>
+            <a:r>
+              <a:t>- "…for the more frequently-used commands, git credential and git submodule are among the most difficult ones." “Difficult” was measured as the share of a command’s questions where the asker never marked an answer as accepted. git credential: 43.0% of 328 questions. git submodule: 37.5% of 2,911. All Git questions together: 36.5% (our count on the paper’s data). A question counts for a command when the command’s name appears in the question or in its accepted answer. Accepting an answer is one click by the asker. The authors note askers may forget it (§5).</a:t>
+            </a:r>
+          </a:p>
+          <a:p>
+            <a:r>
+              <a:t>- "Self-learning is the primary learning approach." The survey was sent to 508 people. 92 answered. The people invited were developers who had recently asked a Git question on Stack Overflow, plus some researchers. Of all the learning approaches ticked, 81.7% were self-learning (161 of 197 ticks). By people: 85 of 92 ticked the internet, 76 the documentation.</a:t>
+            </a:r>
+          </a:p>
+          <a:p>
+            <a:r>
+              <a:t>- "This result, although surprising, is consistent with the conclusion we obtained in RQ2, indicating that even experienced developers still have doubts about Git usage." The 92 rated their own Git level on a five-step scale: novice, advanced beginner, competent, proficient, expert. 79 of 92 chose competent or below. Many of them had used Git for more than five years. Nobody’s Git skill was tested.</a:t>
             </a:r>
           </a:p>
         </p:txBody>
@@ -6425,7 +6425,7 @@
         <p:spPr>
           <a:xfrm>
             <a:off x="822960" y="1831441"/>
-            <a:ext cx="8647535" cy="815440"/>
+            <a:ext cx="8647535" cy="1159661"/>
           </a:xfrm>
           <a:prstGeom prst="rect">
             <a:avLst/>
@@ -6451,7 +6451,7 @@
                 </a:solidFill>
                 <a:latin typeface="Inter"/>
               </a:rPr>
-              <a:t>Your group has one sentence from the paper to check.</a:t>
+              <a:t>Your group has one sentence from the paper, and the facts behind it.</a:t>
             </a:r>
           </a:p>
           <a:p>
@@ -6470,7 +6470,7 @@
                 </a:solidFill>
                 <a:latin typeface="Inter"/>
               </a:rPr>
-              <a:t>Write what the authors measured, then what that really shows.</a:t>
+              <a:t>Write what the facts really show, then what you would need to believe the claim.</a:t>
             </a:r>
           </a:p>
         </p:txBody>
@@ -6483,7 +6483,7 @@
         </p:nvSpPr>
         <p:spPr>
           <a:xfrm>
-            <a:off x="822960" y="2875481"/>
+            <a:off x="822960" y="3219702"/>
             <a:ext cx="5181447" cy="1302145"/>
           </a:xfrm>
           <a:prstGeom prst="roundRect">
@@ -6515,7 +6515,7 @@
         </p:nvSpPr>
         <p:spPr>
           <a:xfrm>
-            <a:off x="1005840" y="3012641"/>
+            <a:off x="1005840" y="3356862"/>
             <a:ext cx="4815687" cy="189321"/>
           </a:xfrm>
           <a:prstGeom prst="rect">
@@ -6552,7 +6552,7 @@
         </p:nvSpPr>
         <p:spPr>
           <a:xfrm>
-            <a:off x="1005840" y="3220250"/>
+            <a:off x="1005840" y="3564471"/>
             <a:ext cx="4815687" cy="774496"/>
           </a:xfrm>
           <a:prstGeom prst="rect">
@@ -6592,7 +6592,7 @@
         </p:nvSpPr>
         <p:spPr>
           <a:xfrm>
-            <a:off x="6187287" y="2875481"/>
+            <a:off x="6187287" y="3219702"/>
             <a:ext cx="5181447" cy="1302145"/>
           </a:xfrm>
           <a:prstGeom prst="roundRect">
@@ -6624,7 +6624,7 @@
         </p:nvSpPr>
         <p:spPr>
           <a:xfrm>
-            <a:off x="6370167" y="3012641"/>
+            <a:off x="6370167" y="3356862"/>
             <a:ext cx="4815687" cy="189321"/>
           </a:xfrm>
           <a:prstGeom prst="rect">
@@ -6661,7 +6661,7 @@
         </p:nvSpPr>
         <p:spPr>
           <a:xfrm>
-            <a:off x="6370167" y="3220250"/>
+            <a:off x="6370167" y="3564471"/>
             <a:ext cx="4815687" cy="774496"/>
           </a:xfrm>
           <a:prstGeom prst="rect">
@@ -6701,7 +6701,7 @@
         </p:nvSpPr>
         <p:spPr>
           <a:xfrm>
-            <a:off x="822960" y="4360506"/>
+            <a:off x="822960" y="4704727"/>
             <a:ext cx="5181447" cy="1560311"/>
           </a:xfrm>
           <a:prstGeom prst="roundRect">
@@ -6733,7 +6733,7 @@
         </p:nvSpPr>
         <p:spPr>
           <a:xfrm>
-            <a:off x="1005840" y="4497666"/>
+            <a:off x="1005840" y="4841887"/>
             <a:ext cx="4815687" cy="189321"/>
           </a:xfrm>
           <a:prstGeom prst="rect">
@@ -6770,7 +6770,7 @@
         </p:nvSpPr>
         <p:spPr>
           <a:xfrm>
-            <a:off x="1005840" y="4705275"/>
+            <a:off x="1005840" y="5049496"/>
             <a:ext cx="4815687" cy="258165"/>
           </a:xfrm>
           <a:prstGeom prst="rect">
@@ -6810,7 +6810,7 @@
         </p:nvSpPr>
         <p:spPr>
           <a:xfrm>
-            <a:off x="6187287" y="4360506"/>
+            <a:off x="6187287" y="4704727"/>
             <a:ext cx="5181447" cy="1560311"/>
           </a:xfrm>
           <a:prstGeom prst="roundRect">
@@ -6842,7 +6842,7 @@
         </p:nvSpPr>
         <p:spPr>
           <a:xfrm>
-            <a:off x="6370167" y="4497666"/>
+            <a:off x="6370167" y="4841887"/>
             <a:ext cx="4815687" cy="189321"/>
           </a:xfrm>
           <a:prstGeom prst="rect">
@@ -6879,7 +6879,7 @@
         </p:nvSpPr>
         <p:spPr>
           <a:xfrm>
-            <a:off x="6370167" y="4705275"/>
+            <a:off x="6370167" y="5049496"/>
             <a:ext cx="4815687" cy="1032662"/>
           </a:xfrm>
           <a:prstGeom prst="rect">

</xml_diff>

<commit_message>
Thursday: every question says what it asks and why
Each activity opens with one plain paragraph on what it is about. Posts ask
'Was this person stuck on X?' with answers that say yes or no. Comments ask
'Which group does this comment belong in?'. The claim and design fields are
full questions with an example each.

Co-Authored-By: Claude Fable 5.1 <noreply@anthropic.com>
</commit_message>
<xml_diff>
--- a/slides/thursday_app.pptx
+++ b/slides/thursday_app.pptx
@@ -753,12 +753,12 @@
           </a:p>
           <a:p>
             <a:r>
-              <a:t>- "This suggests that even developers with years of development experience can have trouble using Git commands." The authors measured experience as the years since the asker joined Stack Overflow. In 2020, 40.0% of Git askers had joined more than 5 years earlier. Among all Stack Overflow askers, 21.2% had. The authors themselves call this a stand-in for experience (§5). Two askers are quoted saying they have programmed for years and still struggle with Git.</a:t>
-            </a:r>
-          </a:p>
-          <a:p>
-            <a:r>
-              <a:t>- "…for the more frequently-used commands, git credential and git submodule are among the most difficult ones." “Difficult” was measured as the share of a command’s questions where the asker never marked an answer as accepted. git credential: 43.0% of 328 questions. git submodule: 37.5% of 2,911. All Git questions together: 36.5% (our count on the paper’s data). A question counts for a command when the command’s name appears in the question or in its accepted answer. Accepting an answer is one click by the asker. The authors note askers may forget it (§5).</a:t>
+              <a:t>- "This suggests that even developers with years of development experience can have trouble using Git commands." The authors measured experience as the years since the asker joined Stack Overflow. In 2020, 40.0% of Git askers had joined more than 5 years earlier. Among all Stack Overflow askers, 21.2% had. The authors themselves call this a stand-in for experience. Two askers are quoted saying they have programmed for years and still struggle with Git.</a:t>
+            </a:r>
+          </a:p>
+          <a:p>
+            <a:r>
+              <a:t>- "…for the more frequently-used commands, git credential and git submodule are among the most difficult ones." “Difficult” was measured as the share of a command’s questions where the asker never marked an answer as accepted. git credential: 43.0% of 328 questions. git submodule: 37.5% of 2,911. All Git questions together: 36.5% (our count on the paper’s data). A question counts for a command when the command’s name appears in the question or in its accepted answer. Accepting an answer is one click by the asker. The authors note askers may forget it.</a:t>
             </a:r>
           </a:p>
           <a:p>
@@ -866,7 +866,7 @@
           </a:p>
           <a:p>
             <a:r>
-              <a:t>- "…for the more frequently-used commands, git credential and git submodule are among the most difficult ones." Measured: The share of a command’s questions that have no accepted answer. Accepting an answer is one click by the asker, and it is often forgotten (§5). And a post counted through its accepted answer has one by definition, so commands that appear in fixes look easy.</a:t>
+              <a:t>- "…for the more frequently-used commands, git credential and git submodule are among the most difficult ones." Measured: The share of a command’s questions that have no accepted answer. Accepting an answer is one click by the asker, and it is often forgotten. And a post counted through its accepted answer has one by definition, so commands that appear in fixes look easy.</a:t>
             </a:r>
           </a:p>
           <a:p>
@@ -974,7 +974,7 @@
           </a:p>
           <a:p>
             <a:r>
-              <a:t>- "…for the more frequently-used commands, git credential and git submodule are among the most difficult ones." Measured: The share of a command’s questions that have no accepted answer. Accepting an answer is one click by the asker, and it is often forgotten (§5). And a post counted through its accepted answer has one by definition, so commands that appear in fixes look easy.</a:t>
+              <a:t>- "…for the more frequently-used commands, git credential and git submodule are among the most difficult ones." Measured: The share of a command’s questions that have no accepted answer. Accepting an answer is one click by the asker, and it is often forgotten. And a post counted through its accepted answer has one by definition, so commands that appear in fixes look easy.</a:t>
             </a:r>
           </a:p>
           <a:p>
@@ -8237,7 +8237,7 @@
         <p:spPr>
           <a:xfrm>
             <a:off x="1005840" y="2943797"/>
-            <a:ext cx="2133523" cy="189321"/>
+            <a:ext cx="2133523" cy="378642"/>
           </a:xfrm>
           <a:prstGeom prst="rect">
             <a:avLst/>
@@ -8260,7 +8260,7 @@
                 </a:solidFill>
                 <a:latin typeface="Inter"/>
               </a:rPr>
-              <a:t>YOUR CHANGE</a:t>
+              <a:t>YOUR CHANGE: WHAT WOULD THE USER SEE OR TYPE?</a:t>
             </a:r>
           </a:p>
         </p:txBody>
@@ -8273,8 +8273,8 @@
         </p:nvSpPr>
         <p:spPr>
           <a:xfrm>
-            <a:off x="1005840" y="3151406"/>
-            <a:ext cx="2133523" cy="481909"/>
+            <a:off x="1005840" y="3340727"/>
+            <a:ext cx="2133523" cy="722863"/>
           </a:xfrm>
           <a:prstGeom prst="rect">
             <a:avLst/>
@@ -8300,7 +8300,7 @@
                 </a:solidFill>
                 <a:latin typeface="Inter"/>
               </a:rPr>
-              <a:t>What the user would see or type</a:t>
+              <a:t>For example: a command that undoes the last thing Git did.</a:t>
             </a:r>
           </a:p>
         </p:txBody>
@@ -8346,7 +8346,7 @@
         <p:spPr>
           <a:xfrm>
             <a:off x="3688003" y="2943797"/>
-            <a:ext cx="2133523" cy="189321"/>
+            <a:ext cx="2133523" cy="378642"/>
           </a:xfrm>
           <a:prstGeom prst="rect">
             <a:avLst/>
@@ -8369,7 +8369,7 @@
                 </a:solidFill>
                 <a:latin typeface="Inter"/>
               </a:rPr>
-              <a:t>HOW YOU WOULD TEST IT</a:t>
+              <a:t>YOUR TEST: WHO WOULD TRY IT, DOING WHAT TASK?</a:t>
             </a:r>
           </a:p>
         </p:txBody>
@@ -8382,8 +8382,8 @@
         </p:nvSpPr>
         <p:spPr>
           <a:xfrm>
-            <a:off x="3688003" y="3151406"/>
-            <a:ext cx="2133523" cy="722863"/>
+            <a:off x="3688003" y="3340727"/>
+            <a:ext cx="2133523" cy="963818"/>
           </a:xfrm>
           <a:prstGeom prst="rect">
             <a:avLst/>
@@ -8409,7 +8409,7 @@
                 </a:solidFill>
                 <a:latin typeface="Inter"/>
               </a:rPr>
-              <a:t>For example: does it cut the time to recover, and for whom?</a:t>
+              <a:t>For example: 20 students who just made a bad commit, half with the change.</a:t>
             </a:r>
           </a:p>
         </p:txBody>
@@ -8455,7 +8455,7 @@
         <p:spPr>
           <a:xfrm>
             <a:off x="6370166" y="2943797"/>
-            <a:ext cx="2133523" cy="378642"/>
+            <a:ext cx="2133523" cy="567964"/>
           </a:xfrm>
           <a:prstGeom prst="rect">
             <a:avLst/>
@@ -8478,7 +8478,7 @@
                 </a:solidFill>
                 <a:latin typeface="Inter"/>
               </a:rPr>
-              <a:t>WHAT YOU WOULD MEASURE, AND ONE RISK</a:t>
+              <a:t>WHAT WOULD YOU MEASURE, AND WHAT COULD FOOL YOU?</a:t>
             </a:r>
           </a:p>
         </p:txBody>
@@ -8491,8 +8491,8 @@
         </p:nvSpPr>
         <p:spPr>
           <a:xfrm>
-            <a:off x="6370166" y="3340727"/>
-            <a:ext cx="2133523" cy="963818"/>
+            <a:off x="6370166" y="3530049"/>
+            <a:ext cx="2133523" cy="722863"/>
           </a:xfrm>
           <a:prstGeom prst="rect">
             <a:avLst/>
@@ -8518,7 +8518,7 @@
                 </a:solidFill>
                 <a:latin typeface="Inter"/>
               </a:rPr>
-              <a:t>For example: time to recover; a risk is that people learn from the first try</a:t>
+              <a:t>For example: time to recover; people get faster on the second try.</a:t>
             </a:r>
           </a:p>
         </p:txBody>
@@ -8564,7 +8564,7 @@
         <p:spPr>
           <a:xfrm>
             <a:off x="9052329" y="2943797"/>
-            <a:ext cx="2133523" cy="378642"/>
+            <a:ext cx="2133523" cy="567964"/>
           </a:xfrm>
           <a:prstGeom prst="rect">
             <a:avLst/>
@@ -8587,7 +8587,7 @@
                 </a:solidFill>
                 <a:latin typeface="Inter"/>
               </a:rPr>
-              <a:t>HOW YOU WOULD COLLECT THE DATA</a:t>
+              <a:t>HOW WOULD YOU GET THE DATA: WATCH PEOPLE, LOG REAL USE, OR ASK THEM?</a:t>
             </a:r>
           </a:p>
         </p:txBody>
@@ -8600,8 +8600,8 @@
         </p:nvSpPr>
         <p:spPr>
           <a:xfrm>
-            <a:off x="9052329" y="3340727"/>
-            <a:ext cx="2133523" cy="722863"/>
+            <a:off x="9052329" y="3530049"/>
+            <a:ext cx="2133523" cy="481909"/>
           </a:xfrm>
           <a:prstGeom prst="rect">
             <a:avLst/>
@@ -8627,7 +8627,7 @@
                 </a:solidFill>
                 <a:latin typeface="Inter"/>
               </a:rPr>
-              <a:t>Would you watch people, log real use, or ask them?</a:t>
+              <a:t>For example: screen recordings of the task.</a:t>
             </a:r>
           </a:p>
         </p:txBody>
@@ -13585,7 +13585,7 @@
         <p:spPr>
           <a:xfrm>
             <a:off x="822960" y="3322968"/>
-            <a:ext cx="3393338" cy="1009558"/>
+            <a:ext cx="3393338" cy="1439833"/>
           </a:xfrm>
           <a:prstGeom prst="roundRect">
             <a:avLst>
@@ -13640,7 +13640,7 @@
                 </a:solidFill>
                 <a:latin typeface="Inter"/>
               </a:rPr>
-              <a:t>STUCK ON IT</a:t>
+              <a:t>YES, STUCK ON IT</a:t>
             </a:r>
           </a:p>
         </p:txBody>
@@ -13680,7 +13680,7 @@
                 </a:solidFill>
                 <a:latin typeface="Inter"/>
               </a:rPr>
-              <a:t>The asker is asking about this command.</a:t>
+              <a:t>They were asking how to use this command.</a:t>
             </a:r>
           </a:p>
         </p:txBody>
@@ -13694,7 +13694,7 @@
         <p:spPr>
           <a:xfrm>
             <a:off x="4399178" y="3322968"/>
-            <a:ext cx="3393338" cy="1009558"/>
+            <a:ext cx="3393338" cy="1439833"/>
           </a:xfrm>
           <a:prstGeom prst="roundRect">
             <a:avLst>
@@ -13726,7 +13726,7 @@
         <p:spPr>
           <a:xfrm>
             <a:off x="4582058" y="3460128"/>
-            <a:ext cx="3027578" cy="189321"/>
+            <a:ext cx="3027578" cy="378642"/>
           </a:xfrm>
           <a:prstGeom prst="rect">
             <a:avLst/>
@@ -13749,7 +13749,7 @@
                 </a:solidFill>
                 <a:latin typeface="Inter"/>
               </a:rPr>
-              <a:t>NEEDS IT BUT DOESN’T KNOW IT</a:t>
+              <a:t>NO. THEY NEEDED IT BUT DID NOT KNOW IT</a:t>
             </a:r>
           </a:p>
         </p:txBody>
@@ -13762,8 +13762,8 @@
         </p:nvSpPr>
         <p:spPr>
           <a:xfrm>
-            <a:off x="4582058" y="3667737"/>
-            <a:ext cx="3027578" cy="481909"/>
+            <a:off x="4582058" y="3857058"/>
+            <a:ext cx="3027578" cy="722863"/>
           </a:xfrm>
           <a:prstGeom prst="rect">
             <a:avLst/>
@@ -13789,7 +13789,7 @@
                 </a:solidFill>
                 <a:latin typeface="Inter"/>
               </a:rPr>
-              <a:t>This command would solve their problem, but they do not know it.</a:t>
+              <a:t>The command would have fixed their problem, but they did not name it.</a:t>
             </a:r>
           </a:p>
         </p:txBody>
@@ -13803,7 +13803,7 @@
         <p:spPr>
           <a:xfrm>
             <a:off x="7975396" y="3322968"/>
-            <a:ext cx="3393338" cy="1009558"/>
+            <a:ext cx="3393338" cy="1439833"/>
           </a:xfrm>
           <a:prstGeom prst="roundRect">
             <a:avLst>
@@ -13858,7 +13858,7 @@
                 </a:solidFill>
                 <a:latin typeface="Inter"/>
               </a:rPr>
-              <a:t>NOT ABOUT IT</a:t>
+              <a:t>NO. IT IS NOT ABOUT IT</a:t>
             </a:r>
           </a:p>
         </p:txBody>
@@ -13898,7 +13898,7 @@
                 </a:solidFill>
                 <a:latin typeface="Inter"/>
               </a:rPr>
-              <a:t>The command is only mentioned; the post is about something else.</a:t>
+              <a:t>The command is only mentioned in passing.</a:t>
             </a:r>
           </a:p>
         </p:txBody>
@@ -13911,7 +13911,7 @@
         </p:nvSpPr>
         <p:spPr>
           <a:xfrm>
-            <a:off x="822960" y="4561126"/>
+            <a:off x="822960" y="4991401"/>
             <a:ext cx="8647535" cy="1152306"/>
           </a:xfrm>
           <a:prstGeom prst="rect">

</xml_diff>

<commit_message>
Thursday: clearer activities (worked examples, plainer questions), simpler post cards; README demo for both days
- Posts: the command top right, one box with the question and the accepted
  answer, then the question to answer; views, year and the counting tag gone
- Design and claims: a worked example on a different problem; fields are
  full questions; per-item questions say what they ask
- Reveals: columns and headings say what the class is looking at
- README: a five-step demo recipe and Thursday screenshots

Co-Authored-By: Claude Fable 5.1 <noreply@anthropic.com>
</commit_message>
<xml_diff>
--- a/slides/thursday_app.pptx
+++ b/slides/thursday_app.pptx
@@ -6484,7 +6484,7 @@
         <p:spPr>
           <a:xfrm>
             <a:off x="822960" y="3219702"/>
-            <a:ext cx="5181447" cy="1302145"/>
+            <a:ext cx="5181447" cy="1094536"/>
           </a:xfrm>
           <a:prstGeom prst="roundRect">
             <a:avLst>
@@ -6516,43 +6516,6 @@
         <p:spPr>
           <a:xfrm>
             <a:off x="1005840" y="3356862"/>
-            <a:ext cx="4815687" cy="189321"/>
-          </a:xfrm>
-          <a:prstGeom prst="rect">
-            <a:avLst/>
-          </a:prstGeom>
-          <a:noFill/>
-        </p:spPr>
-        <p:txBody>
-          <a:bodyPr wrap="square" anchor="t" lIns="0" rIns="0" tIns="0" bIns="0"/>
-          <a:lstStyle/>
-          <a:p>
-            <a:pPr algn="l">
-              <a:lnSpc>
-                <a:spcPct val="110000"/>
-              </a:lnSpc>
-            </a:pPr>
-            <a:r>
-              <a:rPr sz="1100" b="1">
-                <a:solidFill>
-                  <a:srgbClr val="707078"/>
-                </a:solidFill>
-                <a:latin typeface="Inter"/>
-              </a:rPr>
-              <a:t>RQ2, §3.2</a:t>
-            </a:r>
-          </a:p>
-        </p:txBody>
-      </p:sp>
-      <p:sp>
-        <p:nvSpPr>
-          <p:cNvPr id="8" name="TextBox 7"/>
-          <p:cNvSpPr txBox="1"/>
-          <p:nvPr/>
-        </p:nvSpPr>
-        <p:spPr>
-          <a:xfrm>
-            <a:off x="1005840" y="3564471"/>
             <a:ext cx="4815687" cy="774496"/>
           </a:xfrm>
           <a:prstGeom prst="rect">
@@ -6586,14 +6549,14 @@
       </p:sp>
       <p:sp>
         <p:nvSpPr>
-          <p:cNvPr id="9" name="Rounded Rectangle 8"/>
+          <p:cNvPr id="8" name="Rounded Rectangle 7"/>
           <p:cNvSpPr/>
           <p:nvPr/>
         </p:nvSpPr>
         <p:spPr>
           <a:xfrm>
             <a:off x="6187287" y="3219702"/>
-            <a:ext cx="5181447" cy="1302145"/>
+            <a:ext cx="5181447" cy="1094536"/>
           </a:xfrm>
           <a:prstGeom prst="roundRect">
             <a:avLst>
@@ -6618,50 +6581,13 @@
       </p:sp>
       <p:sp>
         <p:nvSpPr>
-          <p:cNvPr id="10" name="TextBox 9"/>
+          <p:cNvPr id="9" name="TextBox 8"/>
           <p:cNvSpPr txBox="1"/>
           <p:nvPr/>
         </p:nvSpPr>
         <p:spPr>
           <a:xfrm>
             <a:off x="6370167" y="3356862"/>
-            <a:ext cx="4815687" cy="189321"/>
-          </a:xfrm>
-          <a:prstGeom prst="rect">
-            <a:avLst/>
-          </a:prstGeom>
-          <a:noFill/>
-        </p:spPr>
-        <p:txBody>
-          <a:bodyPr wrap="square" anchor="t" lIns="0" rIns="0" tIns="0" bIns="0"/>
-          <a:lstStyle/>
-          <a:p>
-            <a:pPr algn="l">
-              <a:lnSpc>
-                <a:spcPct val="110000"/>
-              </a:lnSpc>
-            </a:pPr>
-            <a:r>
-              <a:rPr sz="1100" b="1">
-                <a:solidFill>
-                  <a:srgbClr val="707078"/>
-                </a:solidFill>
-                <a:latin typeface="Inter"/>
-              </a:rPr>
-              <a:t>§1, FINDING 4; §3.4</a:t>
-            </a:r>
-          </a:p>
-        </p:txBody>
-      </p:sp>
-      <p:sp>
-        <p:nvSpPr>
-          <p:cNvPr id="11" name="TextBox 10"/>
-          <p:cNvSpPr txBox="1"/>
-          <p:nvPr/>
-        </p:nvSpPr>
-        <p:spPr>
-          <a:xfrm>
-            <a:off x="6370167" y="3564471"/>
             <a:ext cx="4815687" cy="774496"/>
           </a:xfrm>
           <a:prstGeom prst="rect">
@@ -6695,14 +6621,14 @@
       </p:sp>
       <p:sp>
         <p:nvSpPr>
-          <p:cNvPr id="12" name="Rounded Rectangle 11"/>
+          <p:cNvPr id="10" name="Rounded Rectangle 9"/>
           <p:cNvSpPr/>
           <p:nvPr/>
         </p:nvSpPr>
         <p:spPr>
           <a:xfrm>
-            <a:off x="822960" y="4704727"/>
-            <a:ext cx="5181447" cy="1560311"/>
+            <a:off x="822960" y="4497118"/>
+            <a:ext cx="5181447" cy="1352702"/>
           </a:xfrm>
           <a:prstGeom prst="roundRect">
             <a:avLst>
@@ -6727,50 +6653,13 @@
       </p:sp>
       <p:sp>
         <p:nvSpPr>
-          <p:cNvPr id="13" name="TextBox 12"/>
-          <p:cNvSpPr txBox="1"/>
-          <p:nvPr/>
-        </p:nvSpPr>
-        <p:spPr>
-          <a:xfrm>
-            <a:off x="1005840" y="4841887"/>
-            <a:ext cx="4815687" cy="189321"/>
-          </a:xfrm>
-          <a:prstGeom prst="rect">
-            <a:avLst/>
-          </a:prstGeom>
-          <a:noFill/>
-        </p:spPr>
-        <p:txBody>
-          <a:bodyPr wrap="square" anchor="t" lIns="0" rIns="0" tIns="0" bIns="0"/>
-          <a:lstStyle/>
-          <a:p>
-            <a:pPr algn="l">
-              <a:lnSpc>
-                <a:spcPct val="110000"/>
-              </a:lnSpc>
-            </a:pPr>
-            <a:r>
-              <a:rPr sz="1100" b="1">
-                <a:solidFill>
-                  <a:srgbClr val="707078"/>
-                </a:solidFill>
-                <a:latin typeface="Inter"/>
-              </a:rPr>
-              <a:t>ABSTRACT; §3.5</a:t>
-            </a:r>
-          </a:p>
-        </p:txBody>
-      </p:sp>
-      <p:sp>
-        <p:nvSpPr>
-          <p:cNvPr id="14" name="TextBox 13"/>
-          <p:cNvSpPr txBox="1"/>
-          <p:nvPr/>
-        </p:nvSpPr>
-        <p:spPr>
-          <a:xfrm>
-            <a:off x="1005840" y="5049496"/>
+          <p:cNvPr id="11" name="TextBox 10"/>
+          <p:cNvSpPr txBox="1"/>
+          <p:nvPr/>
+        </p:nvSpPr>
+        <p:spPr>
+          <a:xfrm>
+            <a:off x="1005840" y="4634278"/>
             <a:ext cx="4815687" cy="258165"/>
           </a:xfrm>
           <a:prstGeom prst="rect">
@@ -6804,14 +6693,14 @@
       </p:sp>
       <p:sp>
         <p:nvSpPr>
-          <p:cNvPr id="15" name="Rounded Rectangle 14"/>
+          <p:cNvPr id="12" name="Rounded Rectangle 11"/>
           <p:cNvSpPr/>
           <p:nvPr/>
         </p:nvSpPr>
         <p:spPr>
           <a:xfrm>
-            <a:off x="6187287" y="4704727"/>
-            <a:ext cx="5181447" cy="1560311"/>
+            <a:off x="6187287" y="4497118"/>
+            <a:ext cx="5181447" cy="1352702"/>
           </a:xfrm>
           <a:prstGeom prst="roundRect">
             <a:avLst>
@@ -6836,50 +6725,13 @@
       </p:sp>
       <p:sp>
         <p:nvSpPr>
-          <p:cNvPr id="16" name="TextBox 15"/>
-          <p:cNvSpPr txBox="1"/>
-          <p:nvPr/>
-        </p:nvSpPr>
-        <p:spPr>
-          <a:xfrm>
-            <a:off x="6370167" y="4841887"/>
-            <a:ext cx="4815687" cy="189321"/>
-          </a:xfrm>
-          <a:prstGeom prst="rect">
-            <a:avLst/>
-          </a:prstGeom>
-          <a:noFill/>
-        </p:spPr>
-        <p:txBody>
-          <a:bodyPr wrap="square" anchor="t" lIns="0" rIns="0" tIns="0" bIns="0"/>
-          <a:lstStyle/>
-          <a:p>
-            <a:pPr algn="l">
-              <a:lnSpc>
-                <a:spcPct val="110000"/>
-              </a:lnSpc>
-            </a:pPr>
-            <a:r>
-              <a:rPr sz="1100" b="1">
-                <a:solidFill>
-                  <a:srgbClr val="707078"/>
-                </a:solidFill>
-                <a:latin typeface="Inter"/>
-              </a:rPr>
-              <a:t>§3.5</a:t>
-            </a:r>
-          </a:p>
-        </p:txBody>
-      </p:sp>
-      <p:sp>
-        <p:nvSpPr>
-          <p:cNvPr id="17" name="TextBox 16"/>
-          <p:cNvSpPr txBox="1"/>
-          <p:nvPr/>
-        </p:nvSpPr>
-        <p:spPr>
-          <a:xfrm>
-            <a:off x="6370167" y="5049496"/>
+          <p:cNvPr id="13" name="TextBox 12"/>
+          <p:cNvSpPr txBox="1"/>
+          <p:nvPr/>
+        </p:nvSpPr>
+        <p:spPr>
+          <a:xfrm>
+            <a:off x="6370167" y="4634278"/>
             <a:ext cx="4815687" cy="1032662"/>
           </a:xfrm>
           <a:prstGeom prst="rect">
@@ -7009,7 +6861,7 @@
                 </a:solidFill>
                 <a:latin typeface="Inter"/>
               </a:rPr>
-              <a:t>The four claims, and what the data supports (1/2)</a:t>
+              <a:t>Each claim, and what the data supports (1/2)</a:t>
             </a:r>
           </a:p>
         </p:txBody>
@@ -7023,7 +6875,7 @@
         <p:spPr>
           <a:xfrm>
             <a:off x="822960" y="2519883"/>
-            <a:ext cx="10545775" cy="309798"/>
+            <a:ext cx="10545775" cy="619597"/>
           </a:xfrm>
           <a:prstGeom prst="rect">
             <a:avLst/>
@@ -7049,7 +6901,7 @@
                 </a:solidFill>
                 <a:latin typeface="Inter"/>
               </a:rPr>
-              <a:t>Nobody was watched using Git, so the data cannot answer the paper’s title.</a:t>
+              <a:t>Nobody was watched using Git. So the data cannot answer the question in the paper’s title: do developers know how to use Git commands?</a:t>
             </a:r>
           </a:p>
         </p:txBody>
@@ -7062,7 +6914,7 @@
         </p:nvSpPr>
         <p:spPr>
           <a:xfrm>
-            <a:off x="822960" y="3058281"/>
+            <a:off x="822960" y="3368080"/>
             <a:ext cx="5181447" cy="2292887"/>
           </a:xfrm>
           <a:prstGeom prst="roundRect">
@@ -7094,7 +6946,7 @@
         </p:nvSpPr>
         <p:spPr>
           <a:xfrm>
-            <a:off x="1005840" y="3195441"/>
+            <a:off x="1005840" y="3505240"/>
             <a:ext cx="4815687" cy="774496"/>
           </a:xfrm>
           <a:prstGeom prst="rect">
@@ -7134,7 +6986,7 @@
         </p:nvSpPr>
         <p:spPr>
           <a:xfrm>
-            <a:off x="1005840" y="4061377"/>
+            <a:off x="1005840" y="4371176"/>
             <a:ext cx="4815687" cy="865957"/>
           </a:xfrm>
           <a:prstGeom prst="roundRect">
@@ -7164,7 +7016,7 @@
         </p:nvSpPr>
         <p:spPr>
           <a:xfrm>
-            <a:off x="1097280" y="4116241"/>
+            <a:off x="1097280" y="4426040"/>
             <a:ext cx="4815687" cy="228600"/>
           </a:xfrm>
           <a:prstGeom prst="rect">
@@ -7201,7 +7053,7 @@
         </p:nvSpPr>
         <p:spPr>
           <a:xfrm>
-            <a:off x="1097280" y="4335697"/>
+            <a:off x="1097280" y="4645496"/>
             <a:ext cx="4632807" cy="481909"/>
           </a:xfrm>
           <a:prstGeom prst="rect">
@@ -7241,7 +7093,7 @@
         </p:nvSpPr>
         <p:spPr>
           <a:xfrm>
-            <a:off x="6187287" y="3058281"/>
+            <a:off x="6187287" y="3368080"/>
             <a:ext cx="5181447" cy="2292887"/>
           </a:xfrm>
           <a:prstGeom prst="roundRect">
@@ -7273,7 +7125,7 @@
         </p:nvSpPr>
         <p:spPr>
           <a:xfrm>
-            <a:off x="6370167" y="3195441"/>
+            <a:off x="6370167" y="3505240"/>
             <a:ext cx="4815687" cy="774496"/>
           </a:xfrm>
           <a:prstGeom prst="rect">
@@ -7313,7 +7165,7 @@
         </p:nvSpPr>
         <p:spPr>
           <a:xfrm>
-            <a:off x="6370167" y="4061377"/>
+            <a:off x="6370167" y="4371176"/>
             <a:ext cx="4815687" cy="1106911"/>
           </a:xfrm>
           <a:prstGeom prst="roundRect">
@@ -7343,7 +7195,7 @@
         </p:nvSpPr>
         <p:spPr>
           <a:xfrm>
-            <a:off x="6461607" y="4116241"/>
+            <a:off x="6461607" y="4426040"/>
             <a:ext cx="4815687" cy="228600"/>
           </a:xfrm>
           <a:prstGeom prst="rect">
@@ -7380,7 +7232,7 @@
         </p:nvSpPr>
         <p:spPr>
           <a:xfrm>
-            <a:off x="6461607" y="4335697"/>
+            <a:off x="6461607" y="4645496"/>
             <a:ext cx="4632807" cy="722863"/>
           </a:xfrm>
           <a:prstGeom prst="rect">
@@ -7550,7 +7402,7 @@
                 </a:solidFill>
                 <a:latin typeface="Inter"/>
               </a:rPr>
-              <a:t>The four claims, and what the data supports (2/2)</a:t>
+              <a:t>Each claim, and what the data supports (2/2)</a:t>
             </a:r>
           </a:p>
         </p:txBody>
@@ -7564,7 +7416,7 @@
         <p:spPr>
           <a:xfrm>
             <a:off x="822960" y="2519883"/>
-            <a:ext cx="10545775" cy="309798"/>
+            <a:ext cx="10545775" cy="619597"/>
           </a:xfrm>
           <a:prstGeom prst="rect">
             <a:avLst/>
@@ -7590,7 +7442,7 @@
                 </a:solidFill>
                 <a:latin typeface="Inter"/>
               </a:rPr>
-              <a:t>Nobody was watched using Git, so the data cannot answer the paper’s title.</a:t>
+              <a:t>Nobody was watched using Git. So the data cannot answer the question in the paper’s title: do developers know how to use Git commands?</a:t>
             </a:r>
           </a:p>
         </p:txBody>
@@ -7603,7 +7455,7 @@
         </p:nvSpPr>
         <p:spPr>
           <a:xfrm>
-            <a:off x="822960" y="3058281"/>
+            <a:off x="822960" y="3368080"/>
             <a:ext cx="5181447" cy="2310099"/>
           </a:xfrm>
           <a:prstGeom prst="roundRect">
@@ -7635,7 +7487,7 @@
         </p:nvSpPr>
         <p:spPr>
           <a:xfrm>
-            <a:off x="1005840" y="3195441"/>
+            <a:off x="1005840" y="3505240"/>
             <a:ext cx="4815687" cy="258165"/>
           </a:xfrm>
           <a:prstGeom prst="rect">
@@ -7675,7 +7527,7 @@
         </p:nvSpPr>
         <p:spPr>
           <a:xfrm>
-            <a:off x="1005840" y="3545046"/>
+            <a:off x="1005840" y="3854845"/>
             <a:ext cx="4815687" cy="865957"/>
           </a:xfrm>
           <a:prstGeom prst="roundRect">
@@ -7705,7 +7557,7 @@
         </p:nvSpPr>
         <p:spPr>
           <a:xfrm>
-            <a:off x="1097280" y="3599910"/>
+            <a:off x="1097280" y="3909709"/>
             <a:ext cx="4815687" cy="228600"/>
           </a:xfrm>
           <a:prstGeom prst="rect">
@@ -7742,7 +7594,7 @@
         </p:nvSpPr>
         <p:spPr>
           <a:xfrm>
-            <a:off x="1097280" y="3819366"/>
+            <a:off x="1097280" y="4129165"/>
             <a:ext cx="4632807" cy="481909"/>
           </a:xfrm>
           <a:prstGeom prst="rect">
@@ -7782,7 +7634,7 @@
         </p:nvSpPr>
         <p:spPr>
           <a:xfrm>
-            <a:off x="6187287" y="3058281"/>
+            <a:off x="6187287" y="3368080"/>
             <a:ext cx="5181447" cy="2310099"/>
           </a:xfrm>
           <a:prstGeom prst="roundRect">
@@ -7814,7 +7666,7 @@
         </p:nvSpPr>
         <p:spPr>
           <a:xfrm>
-            <a:off x="6370167" y="3195441"/>
+            <a:off x="6370167" y="3505240"/>
             <a:ext cx="4815687" cy="1032662"/>
           </a:xfrm>
           <a:prstGeom prst="rect">
@@ -7854,7 +7706,7 @@
         </p:nvSpPr>
         <p:spPr>
           <a:xfrm>
-            <a:off x="6370167" y="4319543"/>
+            <a:off x="6370167" y="4629342"/>
             <a:ext cx="4815687" cy="865957"/>
           </a:xfrm>
           <a:prstGeom prst="roundRect">
@@ -7884,7 +7736,7 @@
         </p:nvSpPr>
         <p:spPr>
           <a:xfrm>
-            <a:off x="6461607" y="4374407"/>
+            <a:off x="6461607" y="4684206"/>
             <a:ext cx="4815687" cy="228600"/>
           </a:xfrm>
           <a:prstGeom prst="rect">
@@ -7921,7 +7773,7 @@
         </p:nvSpPr>
         <p:spPr>
           <a:xfrm>
-            <a:off x="6461607" y="4593863"/>
+            <a:off x="6461607" y="4903662"/>
             <a:ext cx="4632807" cy="481909"/>
           </a:xfrm>
           <a:prstGeom prst="rect">
@@ -8146,7 +7998,7 @@
         <p:spPr>
           <a:xfrm>
             <a:off x="822960" y="1831441"/>
-            <a:ext cx="8647535" cy="746596"/>
+            <a:ext cx="8647535" cy="1056395"/>
           </a:xfrm>
           <a:prstGeom prst="rect">
             <a:avLst/>
@@ -8172,7 +8024,61 @@
                 </a:solidFill>
                 <a:latin typeface="Inter"/>
               </a:rPr>
-              <a:t>The most-viewed Git question asks how to undo the last commit.</a:t>
+              <a:t>Git has </a:t>
+            </a:r>
+            <a:r>
+              <a:rPr sz="1800" b="0" i="0">
+                <a:solidFill>
+                  <a:srgbClr val="111111"/>
+                </a:solidFill>
+                <a:latin typeface="Noto Sans Mono"/>
+              </a:rPr>
+              <a:t>reset</a:t>
+            </a:r>
+            <a:r>
+              <a:rPr sz="1800" b="0" i="0">
+                <a:solidFill>
+                  <a:srgbClr val="111111"/>
+                </a:solidFill>
+                <a:latin typeface="Inter"/>
+              </a:rPr>
+              <a:t>, </a:t>
+            </a:r>
+            <a:r>
+              <a:rPr sz="1800" b="0" i="0">
+                <a:solidFill>
+                  <a:srgbClr val="111111"/>
+                </a:solidFill>
+                <a:latin typeface="Noto Sans Mono"/>
+              </a:rPr>
+              <a:t>revert</a:t>
+            </a:r>
+            <a:r>
+              <a:rPr sz="1800" b="0" i="0">
+                <a:solidFill>
+                  <a:srgbClr val="111111"/>
+                </a:solidFill>
+                <a:latin typeface="Inter"/>
+              </a:rPr>
+              <a:t> and </a:t>
+            </a:r>
+            <a:r>
+              <a:rPr sz="1800" b="0" i="0">
+                <a:solidFill>
+                  <a:srgbClr val="111111"/>
+                </a:solidFill>
+                <a:latin typeface="Noto Sans Mono"/>
+              </a:rPr>
+              <a:t>reflog</a:t>
+            </a:r>
+            <a:r>
+              <a:rPr sz="1800" b="0" i="0">
+                <a:solidFill>
+                  <a:srgbClr val="111111"/>
+                </a:solidFill>
+                <a:latin typeface="Inter"/>
+              </a:rPr>
+              <a:t>. Still, the most-viewed Git question is how to undo the last commit.</a:t>
             </a:r>
           </a:p>
           <a:p>
@@ -8191,21 +8097,61 @@
                 </a:solidFill>
                 <a:latin typeface="Inter"/>
               </a:rPr>
-              <a:t>Design one change, and say how you would test whether it helps.</a:t>
-            </a:r>
-          </a:p>
-        </p:txBody>
-      </p:sp>
-      <p:sp>
-        <p:nvSpPr>
-          <p:cNvPr id="6" name="Rounded Rectangle 5"/>
+              <a:t>Design one change that would help, and say how you would test it.</a:t>
+            </a:r>
+          </a:p>
+        </p:txBody>
+      </p:sp>
+      <p:sp>
+        <p:nvSpPr>
+          <p:cNvPr id="6" name="TextBox 5"/>
+          <p:cNvSpPr txBox="1"/>
+          <p:nvPr/>
+        </p:nvSpPr>
+        <p:spPr>
+          <a:xfrm>
+            <a:off x="822960" y="3116436"/>
+            <a:ext cx="10545775" cy="223743"/>
+          </a:xfrm>
+          <a:prstGeom prst="rect">
+            <a:avLst/>
+          </a:prstGeom>
+          <a:noFill/>
+        </p:spPr>
+        <p:txBody>
+          <a:bodyPr wrap="square" anchor="t" lIns="0" rIns="0" tIns="0" bIns="0"/>
+          <a:lstStyle/>
+          <a:p>
+            <a:pPr algn="l">
+              <a:lnSpc>
+                <a:spcPct val="112000"/>
+              </a:lnSpc>
+              <a:spcBef>
+                <a:spcPts val="0"/>
+              </a:spcBef>
+            </a:pPr>
+            <a:r>
+              <a:rPr sz="1300" b="0" i="0">
+                <a:solidFill>
+                  <a:srgbClr val="707078"/>
+                </a:solidFill>
+                <a:latin typeface="Inter"/>
+              </a:rPr>
+              <a:t>An example, for a different problem. The problem: people ask what “detached HEAD” means.</a:t>
+            </a:r>
+          </a:p>
+        </p:txBody>
+      </p:sp>
+      <p:sp>
+        <p:nvSpPr>
+          <p:cNvPr id="7" name="Rounded Rectangle 6"/>
           <p:cNvSpPr/>
           <p:nvPr/>
         </p:nvSpPr>
         <p:spPr>
           <a:xfrm>
-            <a:off x="822960" y="2806637"/>
-            <a:ext cx="2499283" cy="1680788"/>
+            <a:off x="822960" y="3431619"/>
+            <a:ext cx="2499283" cy="2403651"/>
           </a:xfrm>
           <a:prstGeom prst="roundRect">
             <a:avLst>
@@ -8230,14 +8176,14 @@
       </p:sp>
       <p:sp>
         <p:nvSpPr>
-          <p:cNvPr id="7" name="TextBox 6"/>
-          <p:cNvSpPr txBox="1"/>
-          <p:nvPr/>
-        </p:nvSpPr>
-        <p:spPr>
-          <a:xfrm>
-            <a:off x="1005840" y="2943797"/>
-            <a:ext cx="2133523" cy="378642"/>
+          <p:cNvPr id="8" name="TextBox 7"/>
+          <p:cNvSpPr txBox="1"/>
+          <p:nvPr/>
+        </p:nvSpPr>
+        <p:spPr>
+          <a:xfrm>
+            <a:off x="1005840" y="3568779"/>
+            <a:ext cx="2133523" cy="189321"/>
           </a:xfrm>
           <a:prstGeom prst="rect">
             <a:avLst/>
@@ -8260,21 +8206,21 @@
                 </a:solidFill>
                 <a:latin typeface="Inter"/>
               </a:rPr>
-              <a:t>YOUR CHANGE: WHAT WOULD THE USER SEE OR TYPE?</a:t>
-            </a:r>
-          </a:p>
-        </p:txBody>
-      </p:sp>
-      <p:sp>
-        <p:nvSpPr>
-          <p:cNvPr id="8" name="TextBox 7"/>
-          <p:cNvSpPr txBox="1"/>
-          <p:nvPr/>
-        </p:nvSpPr>
-        <p:spPr>
-          <a:xfrm>
-            <a:off x="1005840" y="3340727"/>
-            <a:ext cx="2133523" cy="722863"/>
+              <a:t>THE CHANGE</a:t>
+            </a:r>
+          </a:p>
+        </p:txBody>
+      </p:sp>
+      <p:sp>
+        <p:nvSpPr>
+          <p:cNvPr id="9" name="TextBox 8"/>
+          <p:cNvSpPr txBox="1"/>
+          <p:nvPr/>
+        </p:nvSpPr>
+        <p:spPr>
+          <a:xfrm>
+            <a:off x="1005840" y="3776388"/>
+            <a:ext cx="2133523" cy="1445727"/>
           </a:xfrm>
           <a:prstGeom prst="rect">
             <a:avLst/>
@@ -8300,21 +8246,21 @@
                 </a:solidFill>
                 <a:latin typeface="Inter"/>
               </a:rPr>
-              <a:t>For example: a command that undoes the last thing Git did.</a:t>
-            </a:r>
-          </a:p>
-        </p:txBody>
-      </p:sp>
-      <p:sp>
-        <p:nvSpPr>
-          <p:cNvPr id="9" name="Rounded Rectangle 8"/>
+              <a:t>Replace the long “detached HEAD” notice with two lines: what just happened, and the one command that puts you back on a branch.</a:t>
+            </a:r>
+          </a:p>
+        </p:txBody>
+      </p:sp>
+      <p:sp>
+        <p:nvSpPr>
+          <p:cNvPr id="10" name="Rounded Rectangle 9"/>
           <p:cNvSpPr/>
           <p:nvPr/>
         </p:nvSpPr>
         <p:spPr>
           <a:xfrm>
-            <a:off x="3505123" y="2806637"/>
-            <a:ext cx="2499283" cy="1680788"/>
+            <a:off x="3505123" y="3431619"/>
+            <a:ext cx="2499283" cy="2403651"/>
           </a:xfrm>
           <a:prstGeom prst="roundRect">
             <a:avLst>
@@ -8339,14 +8285,14 @@
       </p:sp>
       <p:sp>
         <p:nvSpPr>
-          <p:cNvPr id="10" name="TextBox 9"/>
-          <p:cNvSpPr txBox="1"/>
-          <p:nvPr/>
-        </p:nvSpPr>
-        <p:spPr>
-          <a:xfrm>
-            <a:off x="3688003" y="2943797"/>
-            <a:ext cx="2133523" cy="378642"/>
+          <p:cNvPr id="11" name="TextBox 10"/>
+          <p:cNvSpPr txBox="1"/>
+          <p:nvPr/>
+        </p:nvSpPr>
+        <p:spPr>
+          <a:xfrm>
+            <a:off x="3688003" y="3568779"/>
+            <a:ext cx="2133523" cy="189321"/>
           </a:xfrm>
           <a:prstGeom prst="rect">
             <a:avLst/>
@@ -8369,21 +8315,21 @@
                 </a:solidFill>
                 <a:latin typeface="Inter"/>
               </a:rPr>
-              <a:t>YOUR TEST: WHO WOULD TRY IT, DOING WHAT TASK?</a:t>
-            </a:r>
-          </a:p>
-        </p:txBody>
-      </p:sp>
-      <p:sp>
-        <p:nvSpPr>
-          <p:cNvPr id="11" name="TextBox 10"/>
-          <p:cNvSpPr txBox="1"/>
-          <p:nvPr/>
-        </p:nvSpPr>
-        <p:spPr>
-          <a:xfrm>
-            <a:off x="3688003" y="3340727"/>
-            <a:ext cx="2133523" cy="963818"/>
+              <a:t>WHO TRIES IT, DOING WHAT</a:t>
+            </a:r>
+          </a:p>
+        </p:txBody>
+      </p:sp>
+      <p:sp>
+        <p:nvSpPr>
+          <p:cNvPr id="12" name="TextBox 11"/>
+          <p:cNvSpPr txBox="1"/>
+          <p:nvPr/>
+        </p:nvSpPr>
+        <p:spPr>
+          <a:xfrm>
+            <a:off x="3688003" y="3776388"/>
+            <a:ext cx="2133523" cy="1445727"/>
           </a:xfrm>
           <a:prstGeom prst="rect">
             <a:avLst/>
@@ -8409,21 +8355,21 @@
                 </a:solidFill>
                 <a:latin typeface="Inter"/>
               </a:rPr>
-              <a:t>For example: 20 students who just made a bad commit, half with the change.</a:t>
-            </a:r>
-          </a:p>
-        </p:txBody>
-      </p:sp>
-      <p:sp>
-        <p:nvSpPr>
-          <p:cNvPr id="12" name="Rounded Rectangle 11"/>
+              <a:t>20 students check out a tag, then are asked to make a commit on a branch. Half see the new message, half the old one.</a:t>
+            </a:r>
+          </a:p>
+        </p:txBody>
+      </p:sp>
+      <p:sp>
+        <p:nvSpPr>
+          <p:cNvPr id="13" name="Rounded Rectangle 12"/>
           <p:cNvSpPr/>
           <p:nvPr/>
         </p:nvSpPr>
         <p:spPr>
           <a:xfrm>
-            <a:off x="6187286" y="2806637"/>
-            <a:ext cx="2499283" cy="1680788"/>
+            <a:off x="6187286" y="3431619"/>
+            <a:ext cx="2499283" cy="2403651"/>
           </a:xfrm>
           <a:prstGeom prst="roundRect">
             <a:avLst>
@@ -8448,14 +8394,14 @@
       </p:sp>
       <p:sp>
         <p:nvSpPr>
-          <p:cNvPr id="13" name="TextBox 12"/>
-          <p:cNvSpPr txBox="1"/>
-          <p:nvPr/>
-        </p:nvSpPr>
-        <p:spPr>
-          <a:xfrm>
-            <a:off x="6370166" y="2943797"/>
-            <a:ext cx="2133523" cy="567964"/>
+          <p:cNvPr id="14" name="TextBox 13"/>
+          <p:cNvSpPr txBox="1"/>
+          <p:nvPr/>
+        </p:nvSpPr>
+        <p:spPr>
+          <a:xfrm>
+            <a:off x="6370166" y="3568779"/>
+            <a:ext cx="2133523" cy="378642"/>
           </a:xfrm>
           <a:prstGeom prst="rect">
             <a:avLst/>
@@ -8478,21 +8424,21 @@
                 </a:solidFill>
                 <a:latin typeface="Inter"/>
               </a:rPr>
-              <a:t>WHAT WOULD YOU MEASURE, AND WHAT COULD FOOL YOU?</a:t>
-            </a:r>
-          </a:p>
-        </p:txBody>
-      </p:sp>
-      <p:sp>
-        <p:nvSpPr>
-          <p:cNvPr id="14" name="TextBox 13"/>
-          <p:cNvSpPr txBox="1"/>
-          <p:nvPr/>
-        </p:nvSpPr>
-        <p:spPr>
-          <a:xfrm>
-            <a:off x="6370166" y="3530049"/>
-            <a:ext cx="2133523" cy="722863"/>
+              <a:t>MEASURE, AND WHAT COULD FOOL YOU</a:t>
+            </a:r>
+          </a:p>
+        </p:txBody>
+      </p:sp>
+      <p:sp>
+        <p:nvSpPr>
+          <p:cNvPr id="15" name="TextBox 14"/>
+          <p:cNvSpPr txBox="1"/>
+          <p:nvPr/>
+        </p:nvSpPr>
+        <p:spPr>
+          <a:xfrm>
+            <a:off x="6370166" y="3965709"/>
+            <a:ext cx="2133523" cy="1686681"/>
           </a:xfrm>
           <a:prstGeom prst="rect">
             <a:avLst/>
@@ -8518,21 +8464,21 @@
                 </a:solidFill>
                 <a:latin typeface="Inter"/>
               </a:rPr>
-              <a:t>For example: time to recover; people get faster on the second try.</a:t>
-            </a:r>
-          </a:p>
-        </p:txBody>
-      </p:sp>
-      <p:sp>
-        <p:nvSpPr>
-          <p:cNvPr id="15" name="Rounded Rectangle 14"/>
+              <a:t>How many are back on a branch within five minutes. What could fool you: students who already knew the fix, if most of them land in one half.</a:t>
+            </a:r>
+          </a:p>
+        </p:txBody>
+      </p:sp>
+      <p:sp>
+        <p:nvSpPr>
+          <p:cNvPr id="16" name="Rounded Rectangle 15"/>
           <p:cNvSpPr/>
           <p:nvPr/>
         </p:nvSpPr>
         <p:spPr>
           <a:xfrm>
-            <a:off x="8869449" y="2806637"/>
-            <a:ext cx="2499283" cy="1680788"/>
+            <a:off x="8869449" y="3431619"/>
+            <a:ext cx="2499283" cy="2403651"/>
           </a:xfrm>
           <a:prstGeom prst="roundRect">
             <a:avLst>
@@ -8557,14 +8503,14 @@
       </p:sp>
       <p:sp>
         <p:nvSpPr>
-          <p:cNvPr id="16" name="TextBox 15"/>
-          <p:cNvSpPr txBox="1"/>
-          <p:nvPr/>
-        </p:nvSpPr>
-        <p:spPr>
-          <a:xfrm>
-            <a:off x="9052329" y="2943797"/>
-            <a:ext cx="2133523" cy="567964"/>
+          <p:cNvPr id="17" name="TextBox 16"/>
+          <p:cNvSpPr txBox="1"/>
+          <p:nvPr/>
+        </p:nvSpPr>
+        <p:spPr>
+          <a:xfrm>
+            <a:off x="9052329" y="3568779"/>
+            <a:ext cx="2133523" cy="189321"/>
           </a:xfrm>
           <a:prstGeom prst="rect">
             <a:avLst/>
@@ -8587,20 +8533,20 @@
                 </a:solidFill>
                 <a:latin typeface="Inter"/>
               </a:rPr>
-              <a:t>HOW WOULD YOU GET THE DATA: WATCH PEOPLE, LOG REAL USE, OR ASK THEM?</a:t>
-            </a:r>
-          </a:p>
-        </p:txBody>
-      </p:sp>
-      <p:sp>
-        <p:nvSpPr>
-          <p:cNvPr id="17" name="TextBox 16"/>
-          <p:cNvSpPr txBox="1"/>
-          <p:nvPr/>
-        </p:nvSpPr>
-        <p:spPr>
-          <a:xfrm>
-            <a:off x="9052329" y="3530049"/>
+              <a:t>HOW YOU GET THE DATA</a:t>
+            </a:r>
+          </a:p>
+        </p:txBody>
+      </p:sp>
+      <p:sp>
+        <p:nvSpPr>
+          <p:cNvPr id="18" name="TextBox 17"/>
+          <p:cNvSpPr txBox="1"/>
+          <p:nvPr/>
+        </p:nvSpPr>
+        <p:spPr>
+          <a:xfrm>
+            <a:off x="9052329" y="3776388"/>
             <a:ext cx="2133523" cy="481909"/>
           </a:xfrm>
           <a:prstGeom prst="rect">
@@ -8627,7 +8573,7 @@
                 </a:solidFill>
                 <a:latin typeface="Inter"/>
               </a:rPr>
-              <a:t>For example: screen recordings of the task.</a:t>
+              <a:t>Watch them do it, with the screen recorded.</a:t>
             </a:r>
           </a:p>
         </p:txBody>
@@ -8744,6 +8690,46 @@
         <p:spPr>
           <a:xfrm>
             <a:off x="822960" y="1831441"/>
+            <a:ext cx="8647535" cy="378642"/>
+          </a:xfrm>
+          <a:prstGeom prst="rect">
+            <a:avLst/>
+          </a:prstGeom>
+          <a:noFill/>
+        </p:spPr>
+        <p:txBody>
+          <a:bodyPr wrap="square" anchor="t" lIns="0" rIns="0" tIns="0" bIns="0"/>
+          <a:lstStyle/>
+          <a:p>
+            <a:pPr algn="l">
+              <a:lnSpc>
+                <a:spcPct val="112000"/>
+              </a:lnSpc>
+              <a:spcBef>
+                <a:spcPts val="0"/>
+              </a:spcBef>
+            </a:pPr>
+            <a:r>
+              <a:rPr sz="2200" b="0" i="0">
+                <a:solidFill>
+                  <a:srgbClr val="111111"/>
+                </a:solidFill>
+                <a:latin typeface="Inter"/>
+              </a:rPr>
+              <a:t>Each group reads out its change and its test.</a:t>
+            </a:r>
+          </a:p>
+        </p:txBody>
+      </p:sp>
+      <p:sp>
+        <p:nvSpPr>
+          <p:cNvPr id="5" name="TextBox 4"/>
+          <p:cNvSpPr txBox="1"/>
+          <p:nvPr/>
+        </p:nvSpPr>
+        <p:spPr>
+          <a:xfrm>
+            <a:off x="822960" y="2438683"/>
             <a:ext cx="8647535" cy="757285"/>
           </a:xfrm>
           <a:prstGeom prst="rect">
@@ -8777,7 +8763,7 @@
       </p:sp>
       <p:sp>
         <p:nvSpPr>
-          <p:cNvPr id="5" name="TextBox 4"/>
+          <p:cNvPr id="6" name="TextBox 5"/>
           <p:cNvSpPr txBox="1"/>
           <p:nvPr/>
         </p:nvSpPr>
@@ -9182,7 +9168,7 @@
                 </a:solidFill>
                 <a:latin typeface="Inter"/>
               </a:rPr>
-              <a:t>✗ The hardness ranking counts a command in the fix as the problem.</a:t>
+              <a:t>✗ The “hardest commands” ranking counts a command named in the fix as if it were the problem.</a:t>
             </a:r>
           </a:p>
           <a:p>
@@ -9238,7 +9224,7 @@
                 </a:solidFill>
                 <a:latin typeface="Inter"/>
               </a:rPr>
-              <a:t>✗ That developers learn on their own was asked of people found on Stack Overflow.</a:t>
+              <a:t>✗ “Developers learn on their own” comes from 92 people, found mostly through Stack Overflow.</a:t>
             </a:r>
           </a:p>
           <a:p>
@@ -10064,7 +10050,7 @@
                 </a:solidFill>
                 <a:latin typeface="Inter"/>
               </a:rPr>
-              <a:t>2. What is your professional area?</a:t>
+              <a:t>1. What is your professional area?</a:t>
             </a:r>
           </a:p>
           <a:p>
@@ -10083,7 +10069,7 @@
                 </a:solidFill>
                 <a:latin typeface="Inter"/>
               </a:rPr>
-              <a:t>3. What is your highest degree?</a:t>
+              <a:t>2. What is your highest degree?</a:t>
             </a:r>
           </a:p>
           <a:p>
@@ -10102,7 +10088,7 @@
                 </a:solidFill>
                 <a:latin typeface="Inter"/>
               </a:rPr>
-              <a:t>4. How many years have you been using Git?</a:t>
+              <a:t>3. How many years have you been using Git?</a:t>
             </a:r>
           </a:p>
           <a:p>
@@ -10121,7 +10107,7 @@
                 </a:solidFill>
                 <a:latin typeface="Inter"/>
               </a:rPr>
-              <a:t>5. Which of the following levels do you consider your ability to use Git to be?</a:t>
+              <a:t>4. Which of the following levels do you consider your ability to use Git to be?</a:t>
             </a:r>
           </a:p>
           <a:p>
@@ -10140,7 +10126,7 @@
                 </a:solidFill>
                 <a:latin typeface="Inter"/>
               </a:rPr>
-              <a:t>6. What are the main approaches you used to learn Git commands?</a:t>
+              <a:t>5. What are the main approaches you used to learn Git commands?</a:t>
             </a:r>
           </a:p>
           <a:p>
@@ -10159,7 +10145,7 @@
                 </a:solidFill>
                 <a:latin typeface="Inter"/>
               </a:rPr>
-              <a:t>7. Do you have any suggestions for potential new developers on learning Git commands</a:t>
+              <a:t>6. Do you have any suggestions for potential new developers on learning Git commands</a:t>
             </a:r>
           </a:p>
         </p:txBody>
@@ -10199,7 +10185,7 @@
                 </a:solidFill>
                 <a:latin typeface="Inter"/>
               </a:rPr>
-              <a:t>Q1 of the form, the donation choice, is left out.</a:t>
+              <a:t>These are Q2 to Q7 of the authors’ form; its Q1, a donation choice, is left out.</a:t>
             </a:r>
           </a:p>
         </p:txBody>

</xml_diff>